<commit_message>
Refactor: Expand presentation to include unsupervised results
Co-authored-by: jahanmateenah55 <jahanmateenah55@gmail.com>
</commit_message>
<xml_diff>
--- a/results/DeepTCR_Results_Presentation.pptx
+++ b/results/DeepTCR_Results_Presentation.pptx
@@ -19,6 +19,12 @@
     <p:sldId id="267" r:id="rId18"/>
     <p:sldId id="268" r:id="rId19"/>
     <p:sldId id="269" r:id="rId20"/>
+    <p:sldId id="270" r:id="rId21"/>
+    <p:sldId id="271" r:id="rId22"/>
+    <p:sldId id="272" r:id="rId23"/>
+    <p:sldId id="273" r:id="rId24"/>
+    <p:sldId id="274" r:id="rId25"/>
+    <p:sldId id="275" r:id="rId26"/>
   </p:sldIdLst>
   <p:sldSz cx="12191695" cy="6858000" type="screen4x3"/>
   <p:notesSz cx="6858000" cy="9144000"/>
@@ -3174,7 +3180,7 @@
               </a:defRPr>
             </a:pPr>
             <a:r>
-              <a:t>DeepTCR for Immunotherapy Response Prediction</a:t>
+              <a:t>DeepTCR-based Prediction of CD19 CAR T-cell Response</a:t>
             </a:r>
           </a:p>
         </p:txBody>
@@ -3209,11 +3215,11 @@
               </a:defRPr>
             </a:pPr>
             <a:r>
-              <a:t>100-Fold Monte Carlo Cross-Validation Analysis</a:t>
+              <a:t>Relapsed/Refractory B-cell Lymphoma (rrLBCL)</a:t>
             </a:r>
             <a:br/>
             <a:r>
-              <a:t>December 2025</a:t>
+              <a:t>Supervised MIL + Unsupervised Representation Learning</a:t>
             </a:r>
           </a:p>
         </p:txBody>
@@ -3309,7 +3315,7 @@
               </a:defRPr>
             </a:pPr>
             <a:r>
-              <a:t>V/J Gene Enrichment Analysis</a:t>
+              <a:t>Model Performance Results</a:t>
             </a:r>
           </a:p>
         </p:txBody>
@@ -3350,7 +3356,7 @@
               </a:defRPr>
             </a:pPr>
             <a:r>
-              <a:t>  V-gene enrichment in high-attention sequences</a:t>
+              <a:t>  Mean AUC: 0.754 +/- 0.035</a:t>
             </a:r>
           </a:p>
           <a:p>
@@ -3368,7 +3374,7 @@
               </a:defRPr>
             </a:pPr>
             <a:r>
-              <a:t>  TRBV20-1 and TRBV7-9 show enrichment</a:t>
+              <a:t>  95% Confidence Interval: [0.747, 0.761]</a:t>
             </a:r>
           </a:p>
           <a:p>
@@ -3386,7 +3392,7 @@
               </a:defRPr>
             </a:pPr>
             <a:r>
-              <a:t>  J-gene usage patterns identified</a:t>
+              <a:t>  Consistent performance across 100 folds</a:t>
             </a:r>
           </a:p>
           <a:p>
@@ -3404,7 +3410,7 @@
               </a:defRPr>
             </a:pPr>
             <a:r>
-              <a:t>  TRBJ2-7 enriched in predictive sequences</a:t>
+              <a:t>  Consistent performance across 100 folds</a:t>
             </a:r>
           </a:p>
           <a:p>
@@ -3422,7 +3428,7 @@
               </a:defRPr>
             </a:pPr>
             <a:r>
-              <a:t>  Gene usage informs biological mechanisms</a:t>
+              <a:t>  Better than random baseline (AUC=0.5)</a:t>
             </a:r>
           </a:p>
           <a:p>
@@ -3440,14 +3446,14 @@
               </a:defRPr>
             </a:pPr>
             <a:r>
-              <a:t>  Consistent with tumor-reactive TCR literature</a:t>
+              <a:t>  Good discriminative ability for clinical use</a:t>
             </a:r>
           </a:p>
         </p:txBody>
       </p:sp>
       <p:pic>
         <p:nvPicPr>
-          <p:cNvPr id="5" name="Picture 4" descr="figure7_gene_usage.png"/>
+          <p:cNvPr id="5" name="Picture 4" descr="figure4_model_performance.png"/>
           <p:cNvPicPr>
             <a:picLocks noChangeAspect="1"/>
           </p:cNvPicPr>
@@ -3462,7 +3468,7 @@
         <p:spPr>
           <a:xfrm>
             <a:off x="5943600" y="1371600"/>
-            <a:ext cx="5760720" cy="2993610"/>
+            <a:ext cx="5760720" cy="2458824"/>
           </a:xfrm>
           <a:prstGeom prst="rect">
             <a:avLst/>
@@ -3496,7 +3502,7 @@
         <p:spPr>
           <a:xfrm>
             <a:off x="0" y="0"/>
-            <a:ext cx="12191695" cy="1097280"/>
+            <a:ext cx="12191695" cy="1005840"/>
           </a:xfrm>
           <a:prstGeom prst="rect">
             <a:avLst/>
@@ -3538,7 +3544,7 @@
         </p:nvSpPr>
         <p:spPr>
           <a:xfrm>
-            <a:off x="457200" y="274320"/>
+            <a:off x="457200" y="228600"/>
             <a:ext cx="11247120" cy="731520"/>
           </a:xfrm>
           <a:prstGeom prst="rect">
@@ -3553,152 +3559,21 @@
           <a:lstStyle/>
           <a:p>
             <a:pPr>
-              <a:defRPr sz="3200" b="1">
+              <a:defRPr sz="3000" b="1">
                 <a:solidFill>
                   <a:srgbClr val="FFFFFF"/>
                 </a:solidFill>
               </a:defRPr>
             </a:pPr>
             <a:r>
-              <a:t>Sequence Characteristics</a:t>
-            </a:r>
-          </a:p>
-        </p:txBody>
-      </p:sp>
-      <p:sp>
-        <p:nvSpPr>
-          <p:cNvPr id="4" name="TextBox 3"/>
-          <p:cNvSpPr txBox="1"/>
-          <p:nvPr/>
-        </p:nvSpPr>
-        <p:spPr>
-          <a:xfrm>
-            <a:off x="457200" y="1371600"/>
-            <a:ext cx="5029200" cy="5029200"/>
-          </a:xfrm>
-          <a:prstGeom prst="rect">
-            <a:avLst/>
-          </a:prstGeom>
-          <a:noFill/>
-        </p:spPr>
-        <p:txBody>
-          <a:bodyPr wrap="square">
-            <a:spAutoFit/>
-          </a:bodyPr>
-          <a:lstStyle/>
-          <a:p>
-            <a:pPr>
-              <a:spcBef>
-                <a:spcPts val="1000"/>
-              </a:spcBef>
-              <a:spcAft>
-                <a:spcPts val="500"/>
-              </a:spcAft>
-              <a:defRPr sz="2000">
-                <a:solidFill>
-                  <a:srgbClr val="2C3E50"/>
-                </a:solidFill>
-              </a:defRPr>
-            </a:pPr>
-            <a:r>
-              <a:t>  CDR3 length: ~14.5 amino acids (mean)</a:t>
-            </a:r>
-          </a:p>
-          <a:p>
-            <a:pPr>
-              <a:spcBef>
-                <a:spcPts val="1000"/>
-              </a:spcBef>
-              <a:spcAft>
-                <a:spcPts val="500"/>
-              </a:spcAft>
-              <a:defRPr sz="2000">
-                <a:solidFill>
-                  <a:srgbClr val="2C3E50"/>
-                </a:solidFill>
-              </a:defRPr>
-            </a:pPr>
-            <a:r>
-              <a:t>  Amino acid composition analysis</a:t>
-            </a:r>
-          </a:p>
-          <a:p>
-            <a:pPr>
-              <a:spcBef>
-                <a:spcPts val="1000"/>
-              </a:spcBef>
-              <a:spcAft>
-                <a:spcPts val="500"/>
-              </a:spcAft>
-              <a:defRPr sz="2000">
-                <a:solidFill>
-                  <a:srgbClr val="2C3E50"/>
-                </a:solidFill>
-              </a:defRPr>
-            </a:pPr>
-            <a:r>
-              <a:t>  Position-specific preferences identified</a:t>
-            </a:r>
-          </a:p>
-          <a:p>
-            <a:pPr>
-              <a:spcBef>
-                <a:spcPts val="1000"/>
-              </a:spcBef>
-              <a:spcAft>
-                <a:spcPts val="500"/>
-              </a:spcAft>
-              <a:defRPr sz="2000">
-                <a:solidFill>
-                  <a:srgbClr val="2C3E50"/>
-                </a:solidFill>
-              </a:defRPr>
-            </a:pPr>
-            <a:r>
-              <a:t>  Hydrophobic/polar balance important</a:t>
-            </a:r>
-          </a:p>
-          <a:p>
-            <a:pPr>
-              <a:spcBef>
-                <a:spcPts val="1000"/>
-              </a:spcBef>
-              <a:spcAft>
-                <a:spcPts val="500"/>
-              </a:spcAft>
-              <a:defRPr sz="2000">
-                <a:solidFill>
-                  <a:srgbClr val="2C3E50"/>
-                </a:solidFill>
-              </a:defRPr>
-            </a:pPr>
-            <a:r>
-              <a:t>  Structural features of predictive sequences</a:t>
-            </a:r>
-          </a:p>
-          <a:p>
-            <a:pPr>
-              <a:spcBef>
-                <a:spcPts val="1000"/>
-              </a:spcBef>
-              <a:spcAft>
-                <a:spcPts val="500"/>
-              </a:spcAft>
-              <a:defRPr sz="2000">
-                <a:solidFill>
-                  <a:srgbClr val="2C3E50"/>
-                </a:solidFill>
-              </a:defRPr>
-            </a:pPr>
-            <a:r>
-              <a:t>  Insights for rational design</a:t>
+              <a:t>Figure 5: Training Dynamics</a:t>
             </a:r>
           </a:p>
         </p:txBody>
       </p:sp>
       <p:pic>
         <p:nvPicPr>
-          <p:cNvPr id="5" name="Picture 4" descr="figure_sequence_characteristics.png"/>
+          <p:cNvPr id="4" name="Picture 3" descr="figure5_training_dynamics.png"/>
           <p:cNvPicPr>
             <a:picLocks noChangeAspect="1"/>
           </p:cNvPicPr>
@@ -3712,14 +3587,49 @@
         </p:blipFill>
         <p:spPr>
           <a:xfrm>
-            <a:off x="5943600" y="1371600"/>
-            <a:ext cx="5760720" cy="5015198"/>
+            <a:off x="640080" y="1234440"/>
+            <a:ext cx="10881360" cy="4846320"/>
           </a:xfrm>
           <a:prstGeom prst="rect">
             <a:avLst/>
           </a:prstGeom>
         </p:spPr>
       </p:pic>
+      <p:sp>
+        <p:nvSpPr>
+          <p:cNvPr id="5" name="TextBox 4"/>
+          <p:cNvSpPr txBox="1"/>
+          <p:nvPr/>
+        </p:nvSpPr>
+        <p:spPr>
+          <a:xfrm>
+            <a:off x="640080" y="5989320"/>
+            <a:ext cx="10881360" cy="731520"/>
+          </a:xfrm>
+          <a:prstGeom prst="rect">
+            <a:avLst/>
+          </a:prstGeom>
+          <a:noFill/>
+        </p:spPr>
+        <p:txBody>
+          <a:bodyPr wrap="square">
+            <a:spAutoFit/>
+          </a:bodyPr>
+          <a:lstStyle/>
+          <a:p>
+            <a:pPr>
+              <a:defRPr sz="1600">
+                <a:solidFill>
+                  <a:srgbClr val="2C3E50"/>
+                </a:solidFill>
+              </a:defRPr>
+            </a:pPr>
+            <a:r>
+              <a:t>Loss/AUC convergence across folds; early stopping behavior</a:t>
+            </a:r>
+          </a:p>
+        </p:txBody>
+      </p:sp>
     </p:spTree>
   </p:cSld>
   <p:clrMapOvr>
@@ -3747,7 +3657,7 @@
         <p:spPr>
           <a:xfrm>
             <a:off x="0" y="0"/>
-            <a:ext cx="12191695" cy="1097280"/>
+            <a:ext cx="12191695" cy="1005840"/>
           </a:xfrm>
           <a:prstGeom prst="rect">
             <a:avLst/>
@@ -3789,7 +3699,7 @@
         </p:nvSpPr>
         <p:spPr>
           <a:xfrm>
-            <a:off x="457200" y="274320"/>
+            <a:off x="457200" y="228600"/>
             <a:ext cx="11247120" cy="731520"/>
           </a:xfrm>
           <a:prstGeom prst="rect">
@@ -3804,28 +3714,52 @@
           <a:lstStyle/>
           <a:p>
             <a:pPr>
-              <a:defRPr sz="3200" b="1">
+              <a:defRPr sz="3000" b="1">
                 <a:solidFill>
                   <a:srgbClr val="FFFFFF"/>
                 </a:solidFill>
               </a:defRPr>
             </a:pPr>
             <a:r>
-              <a:t>Key Findings Summary</a:t>
-            </a:r>
-          </a:p>
-        </p:txBody>
-      </p:sp>
-      <p:sp>
-        <p:nvSpPr>
-          <p:cNvPr id="4" name="TextBox 3"/>
+              <a:t>Attention Weight Analysis</a:t>
+            </a:r>
+          </a:p>
+        </p:txBody>
+      </p:sp>
+      <p:pic>
+        <p:nvPicPr>
+          <p:cNvPr id="4" name="Picture 3" descr="figure6_attention_analysis.png"/>
+          <p:cNvPicPr>
+            <a:picLocks noChangeAspect="1"/>
+          </p:cNvPicPr>
+          <p:nvPr/>
+        </p:nvPicPr>
+        <p:blipFill>
+          <a:blip r:embed="rId2"/>
+          <a:stretch>
+            <a:fillRect/>
+          </a:stretch>
+        </p:blipFill>
+        <p:spPr>
+          <a:xfrm>
+            <a:off x="640080" y="1234440"/>
+            <a:ext cx="10881360" cy="3843703"/>
+          </a:xfrm>
+          <a:prstGeom prst="rect">
+            <a:avLst/>
+          </a:prstGeom>
+        </p:spPr>
+      </p:pic>
+      <p:sp>
+        <p:nvSpPr>
+          <p:cNvPr id="5" name="TextBox 4"/>
           <p:cNvSpPr txBox="1"/>
           <p:nvPr/>
         </p:nvSpPr>
         <p:spPr>
           <a:xfrm>
-            <a:off x="457200" y="1371600"/>
-            <a:ext cx="5303520" cy="5029200"/>
+            <a:off x="640080" y="5989320"/>
+            <a:ext cx="10881360" cy="731520"/>
           </a:xfrm>
           <a:prstGeom prst="rect">
             <a:avLst/>
@@ -3839,295 +3773,14 @@
           <a:lstStyle/>
           <a:p>
             <a:pPr>
-              <a:spcBef>
-                <a:spcPts val="800"/>
-              </a:spcBef>
-              <a:defRPr sz="1800">
+              <a:defRPr sz="1600">
                 <a:solidFill>
                   <a:srgbClr val="2C3E50"/>
                 </a:solidFill>
               </a:defRPr>
             </a:pPr>
             <a:r>
-              <a:t>  Model Performance:</a:t>
-            </a:r>
-          </a:p>
-          <a:p>
-            <a:pPr>
-              <a:spcBef>
-                <a:spcPts val="800"/>
-              </a:spcBef>
-              <a:defRPr sz="1800">
-                <a:solidFill>
-                  <a:srgbClr val="2C3E50"/>
-                </a:solidFill>
-              </a:defRPr>
-            </a:pPr>
-            <a:r>
-              <a:t>     AUC = 0.754 +/- 0.035</a:t>
-            </a:r>
-          </a:p>
-          <a:p>
-            <a:pPr>
-              <a:spcBef>
-                <a:spcPts val="800"/>
-              </a:spcBef>
-              <a:defRPr sz="1800">
-                <a:solidFill>
-                  <a:srgbClr val="2C3E50"/>
-                </a:solidFill>
-              </a:defRPr>
-            </a:pPr>
-            <a:r>
-              <a:t>     Robust across 100 folds</a:t>
-            </a:r>
-          </a:p>
-          <a:p>
-            <a:pPr>
-              <a:spcBef>
-                <a:spcPts val="800"/>
-              </a:spcBef>
-              <a:defRPr sz="1800">
-                <a:solidFill>
-                  <a:srgbClr val="2C3E50"/>
-                </a:solidFill>
-              </a:defRPr>
-            </a:pPr>
-            <a:r>
-              <a:t>     Good clinical utility</a:t>
-            </a:r>
-          </a:p>
-          <a:p>
-            <a:pPr>
-              <a:spcBef>
-                <a:spcPts val="800"/>
-              </a:spcBef>
-              <a:defRPr sz="1800">
-                <a:solidFill>
-                  <a:srgbClr val="2C3E50"/>
-                </a:solidFill>
-              </a:defRPr>
-            </a:pPr>
-            <a:r>
-              <a:t>  </a:t>
-            </a:r>
-          </a:p>
-          <a:p>
-            <a:pPr>
-              <a:spcBef>
-                <a:spcPts val="800"/>
-              </a:spcBef>
-              <a:defRPr sz="1800">
-                <a:solidFill>
-                  <a:srgbClr val="2C3E50"/>
-                </a:solidFill>
-              </a:defRPr>
-            </a:pPr>
-            <a:r>
-              <a:t>  Technical Achievements:</a:t>
-            </a:r>
-          </a:p>
-          <a:p>
-            <a:pPr>
-              <a:spcBef>
-                <a:spcPts val="800"/>
-              </a:spcBef>
-              <a:defRPr sz="1800">
-                <a:solidFill>
-                  <a:srgbClr val="2C3E50"/>
-                </a:solidFill>
-              </a:defRPr>
-            </a:pPr>
-            <a:r>
-              <a:t>     19.2x GPU optimization</a:t>
-            </a:r>
-          </a:p>
-          <a:p>
-            <a:pPr>
-              <a:spcBef>
-                <a:spcPts val="800"/>
-              </a:spcBef>
-              <a:defRPr sz="1800">
-                <a:solidFill>
-                  <a:srgbClr val="2C3E50"/>
-                </a:solidFill>
-              </a:defRPr>
-            </a:pPr>
-            <a:r>
-              <a:t>     35-min training time</a:t>
-            </a:r>
-          </a:p>
-          <a:p>
-            <a:pPr>
-              <a:spcBef>
-                <a:spcPts val="800"/>
-              </a:spcBef>
-              <a:defRPr sz="1800">
-                <a:solidFill>
-                  <a:srgbClr val="2C3E50"/>
-                </a:solidFill>
-              </a:defRPr>
-            </a:pPr>
-            <a:r>
-              <a:t>     Reproducible results</a:t>
-            </a:r>
-          </a:p>
-        </p:txBody>
-      </p:sp>
-      <p:sp>
-        <p:nvSpPr>
-          <p:cNvPr id="5" name="TextBox 4"/>
-          <p:cNvSpPr txBox="1"/>
-          <p:nvPr/>
-        </p:nvSpPr>
-        <p:spPr>
-          <a:xfrm>
-            <a:off x="6217920" y="1371600"/>
-            <a:ext cx="5303520" cy="5029200"/>
-          </a:xfrm>
-          <a:prstGeom prst="rect">
-            <a:avLst/>
-          </a:prstGeom>
-          <a:noFill/>
-        </p:spPr>
-        <p:txBody>
-          <a:bodyPr wrap="square">
-            <a:spAutoFit/>
-          </a:bodyPr>
-          <a:lstStyle/>
-          <a:p>
-            <a:pPr>
-              <a:spcBef>
-                <a:spcPts val="800"/>
-              </a:spcBef>
-              <a:defRPr sz="1800">
-                <a:solidFill>
-                  <a:srgbClr val="2C3E50"/>
-                </a:solidFill>
-              </a:defRPr>
-            </a:pPr>
-            <a:r>
-              <a:t>  Biological Insights:</a:t>
-            </a:r>
-          </a:p>
-          <a:p>
-            <a:pPr>
-              <a:spcBef>
-                <a:spcPts val="800"/>
-              </a:spcBef>
-              <a:defRPr sz="1800">
-                <a:solidFill>
-                  <a:srgbClr val="2C3E50"/>
-                </a:solidFill>
-              </a:defRPr>
-            </a:pPr>
-            <a:r>
-              <a:t>     Attention identifies predictive TCRs</a:t>
-            </a:r>
-          </a:p>
-          <a:p>
-            <a:pPr>
-              <a:spcBef>
-                <a:spcPts val="800"/>
-              </a:spcBef>
-              <a:defRPr sz="1800">
-                <a:solidFill>
-                  <a:srgbClr val="2C3E50"/>
-                </a:solidFill>
-              </a:defRPr>
-            </a:pPr>
-            <a:r>
-              <a:t>     V/J gene enrichment patterns</a:t>
-            </a:r>
-          </a:p>
-          <a:p>
-            <a:pPr>
-              <a:spcBef>
-                <a:spcPts val="800"/>
-              </a:spcBef>
-              <a:defRPr sz="1800">
-                <a:solidFill>
-                  <a:srgbClr val="2C3E50"/>
-                </a:solidFill>
-              </a:defRPr>
-            </a:pPr>
-            <a:r>
-              <a:t>     Sequence characteristics defined</a:t>
-            </a:r>
-          </a:p>
-          <a:p>
-            <a:pPr>
-              <a:spcBef>
-                <a:spcPts val="800"/>
-              </a:spcBef>
-              <a:defRPr sz="1800">
-                <a:solidFill>
-                  <a:srgbClr val="2C3E50"/>
-                </a:solidFill>
-              </a:defRPr>
-            </a:pPr>
-            <a:r>
-              <a:t>  </a:t>
-            </a:r>
-          </a:p>
-          <a:p>
-            <a:pPr>
-              <a:spcBef>
-                <a:spcPts val="800"/>
-              </a:spcBef>
-              <a:defRPr sz="1800">
-                <a:solidFill>
-                  <a:srgbClr val="2C3E50"/>
-                </a:solidFill>
-              </a:defRPr>
-            </a:pPr>
-            <a:r>
-              <a:t>  Clinical Implications:</a:t>
-            </a:r>
-          </a:p>
-          <a:p>
-            <a:pPr>
-              <a:spcBef>
-                <a:spcPts val="800"/>
-              </a:spcBef>
-              <a:defRPr sz="1800">
-                <a:solidFill>
-                  <a:srgbClr val="2C3E50"/>
-                </a:solidFill>
-              </a:defRPr>
-            </a:pPr>
-            <a:r>
-              <a:t>     Pre-treatment prediction possible</a:t>
-            </a:r>
-          </a:p>
-          <a:p>
-            <a:pPr>
-              <a:spcBef>
-                <a:spcPts val="800"/>
-              </a:spcBef>
-              <a:defRPr sz="1800">
-                <a:solidFill>
-                  <a:srgbClr val="2C3E50"/>
-                </a:solidFill>
-              </a:defRPr>
-            </a:pPr>
-            <a:r>
-              <a:t>     Patient stratification enabled</a:t>
-            </a:r>
-          </a:p>
-          <a:p>
-            <a:pPr>
-              <a:spcBef>
-                <a:spcPts val="800"/>
-              </a:spcBef>
-              <a:defRPr sz="1800">
-                <a:solidFill>
-                  <a:srgbClr val="2C3E50"/>
-                </a:solidFill>
-              </a:defRPr>
-            </a:pPr>
-            <a:r>
-              <a:t>     Biomarker candidates identified</a:t>
+              <a:t>Attention highlights a small subset of predictive clonotypes (interpretability)</a:t>
             </a:r>
           </a:p>
         </p:txBody>
@@ -4159,7 +3812,7 @@
         <p:spPr>
           <a:xfrm>
             <a:off x="0" y="0"/>
-            <a:ext cx="12191695" cy="1097280"/>
+            <a:ext cx="12191695" cy="1005840"/>
           </a:xfrm>
           <a:prstGeom prst="rect">
             <a:avLst/>
@@ -4201,7 +3854,7 @@
         </p:nvSpPr>
         <p:spPr>
           <a:xfrm>
-            <a:off x="457200" y="274320"/>
+            <a:off x="457200" y="228600"/>
             <a:ext cx="11247120" cy="731520"/>
           </a:xfrm>
           <a:prstGeom prst="rect">
@@ -4216,28 +3869,52 @@
           <a:lstStyle/>
           <a:p>
             <a:pPr>
-              <a:defRPr sz="3200" b="1">
+              <a:defRPr sz="3000" b="1">
                 <a:solidFill>
                   <a:srgbClr val="FFFFFF"/>
                 </a:solidFill>
               </a:defRPr>
             </a:pPr>
             <a:r>
-              <a:t>Conclusions &amp; Future Directions</a:t>
-            </a:r>
-          </a:p>
-        </p:txBody>
-      </p:sp>
-      <p:sp>
-        <p:nvSpPr>
-          <p:cNvPr id="4" name="TextBox 3"/>
+              <a:t>Figure 7: V/J Gene Usage Patterns</a:t>
+            </a:r>
+          </a:p>
+        </p:txBody>
+      </p:sp>
+      <p:pic>
+        <p:nvPicPr>
+          <p:cNvPr id="4" name="Picture 3" descr="figure7_gene_usage.png"/>
+          <p:cNvPicPr>
+            <a:picLocks noChangeAspect="1"/>
+          </p:cNvPicPr>
+          <p:nvPr/>
+        </p:nvPicPr>
+        <p:blipFill>
+          <a:blip r:embed="rId2"/>
+          <a:stretch>
+            <a:fillRect/>
+          </a:stretch>
+        </p:blipFill>
+        <p:spPr>
+          <a:xfrm>
+            <a:off x="640080" y="1234440"/>
+            <a:ext cx="10881360" cy="5654597"/>
+          </a:xfrm>
+          <a:prstGeom prst="rect">
+            <a:avLst/>
+          </a:prstGeom>
+        </p:spPr>
+      </p:pic>
+      <p:sp>
+        <p:nvSpPr>
+          <p:cNvPr id="5" name="TextBox 4"/>
           <p:cNvSpPr txBox="1"/>
           <p:nvPr/>
         </p:nvSpPr>
         <p:spPr>
           <a:xfrm>
-            <a:off x="457200" y="1371600"/>
-            <a:ext cx="11247120" cy="5029200"/>
+            <a:off x="640080" y="5989320"/>
+            <a:ext cx="10881360" cy="731520"/>
           </a:xfrm>
           <a:prstGeom prst="rect">
             <a:avLst/>
@@ -4251,164 +3928,14 @@
           <a:lstStyle/>
           <a:p>
             <a:pPr>
-              <a:spcBef>
-                <a:spcPts val="1000"/>
-              </a:spcBef>
-              <a:spcAft>
-                <a:spcPts val="500"/>
-              </a:spcAft>
-              <a:defRPr sz="2000">
+              <a:defRPr sz="1600">
                 <a:solidFill>
                   <a:srgbClr val="2C3E50"/>
                 </a:solidFill>
               </a:defRPr>
             </a:pPr>
             <a:r>
-              <a:t>  DeepTCR successfully predicts immunotherapy response</a:t>
-            </a:r>
-          </a:p>
-          <a:p>
-            <a:pPr>
-              <a:spcBef>
-                <a:spcPts val="1000"/>
-              </a:spcBef>
-              <a:spcAft>
-                <a:spcPts val="500"/>
-              </a:spcAft>
-              <a:defRPr sz="2000">
-                <a:solidFill>
-                  <a:srgbClr val="2C3E50"/>
-                </a:solidFill>
-              </a:defRPr>
-            </a:pPr>
-            <a:r>
-              <a:t>  Attention mechanism provides interpretability</a:t>
-            </a:r>
-          </a:p>
-          <a:p>
-            <a:pPr>
-              <a:spcBef>
-                <a:spcPts val="1000"/>
-              </a:spcBef>
-              <a:spcAft>
-                <a:spcPts val="500"/>
-              </a:spcAft>
-              <a:defRPr sz="2000">
-                <a:solidFill>
-                  <a:srgbClr val="2C3E50"/>
-                </a:solidFill>
-              </a:defRPr>
-            </a:pPr>
-            <a:r>
-              <a:t>  TCR repertoire contains predictive information</a:t>
-            </a:r>
-          </a:p>
-          <a:p>
-            <a:pPr>
-              <a:spcBef>
-                <a:spcPts val="1000"/>
-              </a:spcBef>
-              <a:spcAft>
-                <a:spcPts val="500"/>
-              </a:spcAft>
-              <a:defRPr sz="2000">
-                <a:solidFill>
-                  <a:srgbClr val="2C3E50"/>
-                </a:solidFill>
-              </a:defRPr>
-            </a:pPr>
-            <a:r>
-              <a:t>  </a:t>
-            </a:r>
-          </a:p>
-          <a:p>
-            <a:pPr>
-              <a:spcBef>
-                <a:spcPts val="1000"/>
-              </a:spcBef>
-              <a:spcAft>
-                <a:spcPts val="500"/>
-              </a:spcAft>
-              <a:defRPr sz="2000">
-                <a:solidFill>
-                  <a:srgbClr val="2C3E50"/>
-                </a:solidFill>
-              </a:defRPr>
-            </a:pPr>
-            <a:r>
-              <a:t>  Future work:</a:t>
-            </a:r>
-          </a:p>
-          <a:p>
-            <a:pPr>
-              <a:spcBef>
-                <a:spcPts val="1000"/>
-              </a:spcBef>
-              <a:spcAft>
-                <a:spcPts val="500"/>
-              </a:spcAft>
-              <a:defRPr sz="2000">
-                <a:solidFill>
-                  <a:srgbClr val="2C3E50"/>
-                </a:solidFill>
-              </a:defRPr>
-            </a:pPr>
-            <a:r>
-              <a:t>     Validation in independent cohorts</a:t>
-            </a:r>
-          </a:p>
-          <a:p>
-            <a:pPr>
-              <a:spcBef>
-                <a:spcPts val="1000"/>
-              </a:spcBef>
-              <a:spcAft>
-                <a:spcPts val="500"/>
-              </a:spcAft>
-              <a:defRPr sz="2000">
-                <a:solidFill>
-                  <a:srgbClr val="2C3E50"/>
-                </a:solidFill>
-              </a:defRPr>
-            </a:pPr>
-            <a:r>
-              <a:t>     Integration with other biomarkers</a:t>
-            </a:r>
-          </a:p>
-          <a:p>
-            <a:pPr>
-              <a:spcBef>
-                <a:spcPts val="1000"/>
-              </a:spcBef>
-              <a:spcAft>
-                <a:spcPts val="500"/>
-              </a:spcAft>
-              <a:defRPr sz="2000">
-                <a:solidFill>
-                  <a:srgbClr val="2C3E50"/>
-                </a:solidFill>
-              </a:defRPr>
-            </a:pPr>
-            <a:r>
-              <a:t>     Prospective clinical study</a:t>
-            </a:r>
-          </a:p>
-          <a:p>
-            <a:pPr>
-              <a:spcBef>
-                <a:spcPts val="1000"/>
-              </a:spcBef>
-              <a:spcAft>
-                <a:spcPts val="500"/>
-              </a:spcAft>
-              <a:defRPr sz="2000">
-                <a:solidFill>
-                  <a:srgbClr val="2C3E50"/>
-                </a:solidFill>
-              </a:defRPr>
-            </a:pPr>
-            <a:r>
-              <a:t>     Mechanistic characterization of top sequences</a:t>
+              <a:t>Gene usage differences and enrichment patterns in high-attention sequences</a:t>
             </a:r>
           </a:p>
         </p:txBody>
@@ -4440,7 +3967,7 @@
         <p:spPr>
           <a:xfrm>
             <a:off x="0" y="0"/>
-            <a:ext cx="12191695" cy="6858000"/>
+            <a:ext cx="12191695" cy="1005840"/>
           </a:xfrm>
           <a:prstGeom prst="rect">
             <a:avLst/>
@@ -4482,8 +4009,8 @@
         </p:nvSpPr>
         <p:spPr>
           <a:xfrm>
-            <a:off x="457200" y="2286000"/>
-            <a:ext cx="11247120" cy="1371600"/>
+            <a:off x="457200" y="228600"/>
+            <a:ext cx="11247120" cy="731520"/>
           </a:xfrm>
           <a:prstGeom prst="rect">
             <a:avLst/>
@@ -4496,29 +4023,149 @@
           </a:bodyPr>
           <a:lstStyle/>
           <a:p>
-            <a:pPr algn="ctr">
-              <a:defRPr sz="4400" b="1">
+            <a:pPr>
+              <a:defRPr sz="3000" b="1">
                 <a:solidFill>
                   <a:srgbClr val="FFFFFF"/>
                 </a:solidFill>
               </a:defRPr>
             </a:pPr>
             <a:r>
-              <a:t>Thank You</a:t>
-            </a:r>
-          </a:p>
-        </p:txBody>
-      </p:sp>
-      <p:sp>
-        <p:nvSpPr>
-          <p:cNvPr id="4" name="TextBox 3"/>
+              <a:t>Figure S7: Top Predictive Sequences</a:t>
+            </a:r>
+          </a:p>
+        </p:txBody>
+      </p:sp>
+      <p:pic>
+        <p:nvPicPr>
+          <p:cNvPr id="4" name="Picture 3" descr="figureS7_top_sequences.png"/>
+          <p:cNvPicPr>
+            <a:picLocks noChangeAspect="1"/>
+          </p:cNvPicPr>
+          <p:nvPr/>
+        </p:nvPicPr>
+        <p:blipFill>
+          <a:blip r:embed="rId2"/>
+          <a:stretch>
+            <a:fillRect/>
+          </a:stretch>
+        </p:blipFill>
+        <p:spPr>
+          <a:xfrm>
+            <a:off x="640080" y="1234440"/>
+            <a:ext cx="10881360" cy="8987930"/>
+          </a:xfrm>
+          <a:prstGeom prst="rect">
+            <a:avLst/>
+          </a:prstGeom>
+        </p:spPr>
+      </p:pic>
+      <p:sp>
+        <p:nvSpPr>
+          <p:cNvPr id="5" name="TextBox 4"/>
           <p:cNvSpPr txBox="1"/>
           <p:nvPr/>
         </p:nvSpPr>
         <p:spPr>
           <a:xfrm>
-            <a:off x="457200" y="3840480"/>
-            <a:ext cx="11247120" cy="914400"/>
+            <a:off x="640080" y="5989320"/>
+            <a:ext cx="10881360" cy="731520"/>
+          </a:xfrm>
+          <a:prstGeom prst="rect">
+            <a:avLst/>
+          </a:prstGeom>
+          <a:noFill/>
+        </p:spPr>
+        <p:txBody>
+          <a:bodyPr wrap="square">
+            <a:spAutoFit/>
+          </a:bodyPr>
+          <a:lstStyle/>
+          <a:p>
+            <a:pPr>
+              <a:defRPr sz="1600">
+                <a:solidFill>
+                  <a:srgbClr val="2C3E50"/>
+                </a:solidFill>
+              </a:defRPr>
+            </a:pPr>
+            <a:r>
+              <a:t>Top sequences by attention; V/J enrichment; responder vs non-responder distribution</a:t>
+            </a:r>
+          </a:p>
+        </p:txBody>
+      </p:sp>
+    </p:spTree>
+  </p:cSld>
+  <p:clrMapOvr>
+    <a:masterClrMapping/>
+  </p:clrMapOvr>
+</p:sld>
+</file>
+
+<file path=ppt/slides/slide15.xml><?xml version="1.0" encoding="utf-8"?>
+<p:sld xmlns:a="http://schemas.openxmlformats.org/drawingml/2006/main" xmlns:p="http://schemas.openxmlformats.org/presentationml/2006/main" xmlns:r="http://schemas.openxmlformats.org/officeDocument/2006/relationships">
+  <p:cSld>
+    <p:spTree>
+      <p:nvGrpSpPr>
+        <p:cNvPr id="1" name=""/>
+        <p:cNvGrpSpPr/>
+        <p:nvPr/>
+      </p:nvGrpSpPr>
+      <p:grpSpPr/>
+      <p:sp>
+        <p:nvSpPr>
+          <p:cNvPr id="2" name="Rectangle 1"/>
+          <p:cNvSpPr/>
+          <p:nvPr/>
+        </p:nvSpPr>
+        <p:spPr>
+          <a:xfrm>
+            <a:off x="0" y="0"/>
+            <a:ext cx="12191695" cy="1005840"/>
+          </a:xfrm>
+          <a:prstGeom prst="rect">
+            <a:avLst/>
+          </a:prstGeom>
+          <a:solidFill>
+            <a:srgbClr val="2C3E50"/>
+          </a:solidFill>
+          <a:ln>
+            <a:noFill/>
+          </a:ln>
+        </p:spPr>
+        <p:style>
+          <a:lnRef idx="1">
+            <a:schemeClr val="accent1"/>
+          </a:lnRef>
+          <a:fillRef idx="3">
+            <a:schemeClr val="accent1"/>
+          </a:fillRef>
+          <a:effectRef idx="2">
+            <a:schemeClr val="accent1"/>
+          </a:effectRef>
+          <a:fontRef idx="minor">
+            <a:schemeClr val="lt1"/>
+          </a:fontRef>
+        </p:style>
+        <p:txBody>
+          <a:bodyPr rtlCol="0" anchor="ctr"/>
+          <a:lstStyle/>
+          <a:p>
+            <a:pPr algn="ctr"/>
+          </a:p>
+        </p:txBody>
+      </p:sp>
+      <p:sp>
+        <p:nvSpPr>
+          <p:cNvPr id="3" name="TextBox 2"/>
+          <p:cNvSpPr txBox="1"/>
+          <p:nvPr/>
+        </p:nvSpPr>
+        <p:spPr>
+          <a:xfrm>
+            <a:off x="457200" y="228600"/>
+            <a:ext cx="11247120" cy="731520"/>
           </a:xfrm>
           <a:prstGeom prst="rect">
             <a:avLst/>
@@ -4531,20 +4178,897 @@
           </a:bodyPr>
           <a:lstStyle/>
           <a:p>
-            <a:pPr algn="ctr">
-              <a:defRPr sz="2400">
+            <a:pPr>
+              <a:defRPr sz="3000" b="1">
                 <a:solidFill>
                   <a:srgbClr val="FFFFFF"/>
                 </a:solidFill>
               </a:defRPr>
             </a:pPr>
             <a:r>
-              <a:t>Questions?</a:t>
-            </a:r>
-            <a:br/>
-            <a:br/>
-            <a:r>
-              <a:t>Generated with DeepTCR Pipeline</a:t>
+              <a:t>Figure S9: Sequence Characteristics</a:t>
+            </a:r>
+          </a:p>
+        </p:txBody>
+      </p:sp>
+      <p:pic>
+        <p:nvPicPr>
+          <p:cNvPr id="4" name="Picture 3" descr="figureS9_sequence_characteristics.png"/>
+          <p:cNvPicPr>
+            <a:picLocks noChangeAspect="1"/>
+          </p:cNvPicPr>
+          <p:nvPr/>
+        </p:nvPicPr>
+        <p:blipFill>
+          <a:blip r:embed="rId2"/>
+          <a:stretch>
+            <a:fillRect/>
+          </a:stretch>
+        </p:blipFill>
+        <p:spPr>
+          <a:xfrm>
+            <a:off x="640080" y="1234440"/>
+            <a:ext cx="10881360" cy="9473152"/>
+          </a:xfrm>
+          <a:prstGeom prst="rect">
+            <a:avLst/>
+          </a:prstGeom>
+        </p:spPr>
+      </p:pic>
+      <p:sp>
+        <p:nvSpPr>
+          <p:cNvPr id="5" name="TextBox 4"/>
+          <p:cNvSpPr txBox="1"/>
+          <p:nvPr/>
+        </p:nvSpPr>
+        <p:spPr>
+          <a:xfrm>
+            <a:off x="640080" y="5989320"/>
+            <a:ext cx="10881360" cy="731520"/>
+          </a:xfrm>
+          <a:prstGeom prst="rect">
+            <a:avLst/>
+          </a:prstGeom>
+          <a:noFill/>
+        </p:spPr>
+        <p:txBody>
+          <a:bodyPr wrap="square">
+            <a:spAutoFit/>
+          </a:bodyPr>
+          <a:lstStyle/>
+          <a:p>
+            <a:pPr>
+              <a:defRPr sz="1600">
+                <a:solidFill>
+                  <a:srgbClr val="2C3E50"/>
+                </a:solidFill>
+              </a:defRPr>
+            </a:pPr>
+            <a:r>
+              <a:t>Length and amino-acid composition differences for high-attention sequences</a:t>
+            </a:r>
+          </a:p>
+        </p:txBody>
+      </p:sp>
+    </p:spTree>
+  </p:cSld>
+  <p:clrMapOvr>
+    <a:masterClrMapping/>
+  </p:clrMapOvr>
+</p:sld>
+</file>
+
+<file path=ppt/slides/slide16.xml><?xml version="1.0" encoding="utf-8"?>
+<p:sld xmlns:a="http://schemas.openxmlformats.org/drawingml/2006/main" xmlns:p="http://schemas.openxmlformats.org/presentationml/2006/main" xmlns:r="http://schemas.openxmlformats.org/officeDocument/2006/relationships">
+  <p:cSld>
+    <p:spTree>
+      <p:nvGrpSpPr>
+        <p:cNvPr id="1" name=""/>
+        <p:cNvGrpSpPr/>
+        <p:nvPr/>
+      </p:nvGrpSpPr>
+      <p:grpSpPr/>
+      <p:sp>
+        <p:nvSpPr>
+          <p:cNvPr id="2" name="Rectangle 1"/>
+          <p:cNvSpPr/>
+          <p:nvPr/>
+        </p:nvSpPr>
+        <p:spPr>
+          <a:xfrm>
+            <a:off x="0" y="0"/>
+            <a:ext cx="12191695" cy="1005840"/>
+          </a:xfrm>
+          <a:prstGeom prst="rect">
+            <a:avLst/>
+          </a:prstGeom>
+          <a:solidFill>
+            <a:srgbClr val="2C3E50"/>
+          </a:solidFill>
+          <a:ln>
+            <a:noFill/>
+          </a:ln>
+        </p:spPr>
+        <p:style>
+          <a:lnRef idx="1">
+            <a:schemeClr val="accent1"/>
+          </a:lnRef>
+          <a:fillRef idx="3">
+            <a:schemeClr val="accent1"/>
+          </a:fillRef>
+          <a:effectRef idx="2">
+            <a:schemeClr val="accent1"/>
+          </a:effectRef>
+          <a:fontRef idx="minor">
+            <a:schemeClr val="lt1"/>
+          </a:fontRef>
+        </p:style>
+        <p:txBody>
+          <a:bodyPr rtlCol="0" anchor="ctr"/>
+          <a:lstStyle/>
+          <a:p>
+            <a:pPr algn="ctr"/>
+          </a:p>
+        </p:txBody>
+      </p:sp>
+      <p:sp>
+        <p:nvSpPr>
+          <p:cNvPr id="3" name="TextBox 2"/>
+          <p:cNvSpPr txBox="1"/>
+          <p:nvPr/>
+        </p:nvSpPr>
+        <p:spPr>
+          <a:xfrm>
+            <a:off x="457200" y="228600"/>
+            <a:ext cx="11247120" cy="731520"/>
+          </a:xfrm>
+          <a:prstGeom prst="rect">
+            <a:avLst/>
+          </a:prstGeom>
+          <a:noFill/>
+        </p:spPr>
+        <p:txBody>
+          <a:bodyPr wrap="none">
+            <a:spAutoFit/>
+          </a:bodyPr>
+          <a:lstStyle/>
+          <a:p>
+            <a:pPr>
+              <a:defRPr sz="3000" b="1">
+                <a:solidFill>
+                  <a:srgbClr val="FFFFFF"/>
+                </a:solidFill>
+              </a:defRPr>
+            </a:pPr>
+            <a:r>
+              <a:t>Figure S11: Unsupervised Sequence Space (UMAP)</a:t>
+            </a:r>
+          </a:p>
+        </p:txBody>
+      </p:sp>
+      <p:pic>
+        <p:nvPicPr>
+          <p:cNvPr id="4" name="Picture 3" descr="figureS11_unsupervised_sequence_space.png"/>
+          <p:cNvPicPr>
+            <a:picLocks noChangeAspect="1"/>
+          </p:cNvPicPr>
+          <p:nvPr/>
+        </p:nvPicPr>
+        <p:blipFill>
+          <a:blip r:embed="rId2"/>
+          <a:stretch>
+            <a:fillRect/>
+          </a:stretch>
+        </p:blipFill>
+        <p:spPr>
+          <a:xfrm>
+            <a:off x="640080" y="1234440"/>
+            <a:ext cx="10881360" cy="4344109"/>
+          </a:xfrm>
+          <a:prstGeom prst="rect">
+            <a:avLst/>
+          </a:prstGeom>
+        </p:spPr>
+      </p:pic>
+      <p:sp>
+        <p:nvSpPr>
+          <p:cNvPr id="5" name="TextBox 4"/>
+          <p:cNvSpPr txBox="1"/>
+          <p:nvPr/>
+        </p:nvSpPr>
+        <p:spPr>
+          <a:xfrm>
+            <a:off x="640080" y="5989320"/>
+            <a:ext cx="10881360" cy="731520"/>
+          </a:xfrm>
+          <a:prstGeom prst="rect">
+            <a:avLst/>
+          </a:prstGeom>
+          <a:noFill/>
+        </p:spPr>
+        <p:txBody>
+          <a:bodyPr wrap="square">
+            <a:spAutoFit/>
+          </a:bodyPr>
+          <a:lstStyle/>
+          <a:p>
+            <a:pPr>
+              <a:defRPr sz="1600">
+                <a:solidFill>
+                  <a:srgbClr val="2C3E50"/>
+                </a:solidFill>
+              </a:defRPr>
+            </a:pPr>
+            <a:r>
+              <a:t>R=green, NR=orange; black outline = top attention (supervised importance)</a:t>
+            </a:r>
+          </a:p>
+        </p:txBody>
+      </p:sp>
+    </p:spTree>
+  </p:cSld>
+  <p:clrMapOvr>
+    <a:masterClrMapping/>
+  </p:clrMapOvr>
+</p:sld>
+</file>
+
+<file path=ppt/slides/slide17.xml><?xml version="1.0" encoding="utf-8"?>
+<p:sld xmlns:a="http://schemas.openxmlformats.org/drawingml/2006/main" xmlns:p="http://schemas.openxmlformats.org/presentationml/2006/main" xmlns:r="http://schemas.openxmlformats.org/officeDocument/2006/relationships">
+  <p:cSld>
+    <p:spTree>
+      <p:nvGrpSpPr>
+        <p:cNvPr id="1" name=""/>
+        <p:cNvGrpSpPr/>
+        <p:nvPr/>
+      </p:nvGrpSpPr>
+      <p:grpSpPr/>
+      <p:sp>
+        <p:nvSpPr>
+          <p:cNvPr id="2" name="Rectangle 1"/>
+          <p:cNvSpPr/>
+          <p:nvPr/>
+        </p:nvSpPr>
+        <p:spPr>
+          <a:xfrm>
+            <a:off x="0" y="0"/>
+            <a:ext cx="12191695" cy="1005840"/>
+          </a:xfrm>
+          <a:prstGeom prst="rect">
+            <a:avLst/>
+          </a:prstGeom>
+          <a:solidFill>
+            <a:srgbClr val="2C3E50"/>
+          </a:solidFill>
+          <a:ln>
+            <a:noFill/>
+          </a:ln>
+        </p:spPr>
+        <p:style>
+          <a:lnRef idx="1">
+            <a:schemeClr val="accent1"/>
+          </a:lnRef>
+          <a:fillRef idx="3">
+            <a:schemeClr val="accent1"/>
+          </a:fillRef>
+          <a:effectRef idx="2">
+            <a:schemeClr val="accent1"/>
+          </a:effectRef>
+          <a:fontRef idx="minor">
+            <a:schemeClr val="lt1"/>
+          </a:fontRef>
+        </p:style>
+        <p:txBody>
+          <a:bodyPr rtlCol="0" anchor="ctr"/>
+          <a:lstStyle/>
+          <a:p>
+            <a:pPr algn="ctr"/>
+          </a:p>
+        </p:txBody>
+      </p:sp>
+      <p:sp>
+        <p:nvSpPr>
+          <p:cNvPr id="3" name="TextBox 2"/>
+          <p:cNvSpPr txBox="1"/>
+          <p:nvPr/>
+        </p:nvSpPr>
+        <p:spPr>
+          <a:xfrm>
+            <a:off x="457200" y="228600"/>
+            <a:ext cx="11247120" cy="731520"/>
+          </a:xfrm>
+          <a:prstGeom prst="rect">
+            <a:avLst/>
+          </a:prstGeom>
+          <a:noFill/>
+        </p:spPr>
+        <p:txBody>
+          <a:bodyPr wrap="none">
+            <a:spAutoFit/>
+          </a:bodyPr>
+          <a:lstStyle/>
+          <a:p>
+            <a:pPr>
+              <a:defRPr sz="3000" b="1">
+                <a:solidFill>
+                  <a:srgbClr val="FFFFFF"/>
+                </a:solidFill>
+              </a:defRPr>
+            </a:pPr>
+            <a:r>
+              <a:t>Figure S10: Patient Embedding (PCA)</a:t>
+            </a:r>
+          </a:p>
+        </p:txBody>
+      </p:sp>
+      <p:pic>
+        <p:nvPicPr>
+          <p:cNvPr id="4" name="Picture 3" descr="figureS10_unsupervised_patient_clusters.png"/>
+          <p:cNvPicPr>
+            <a:picLocks noChangeAspect="1"/>
+          </p:cNvPicPr>
+          <p:nvPr/>
+        </p:nvPicPr>
+        <p:blipFill>
+          <a:blip r:embed="rId2"/>
+          <a:stretch>
+            <a:fillRect/>
+          </a:stretch>
+        </p:blipFill>
+        <p:spPr>
+          <a:xfrm>
+            <a:off x="640080" y="1234440"/>
+            <a:ext cx="10881360" cy="7900771"/>
+          </a:xfrm>
+          <a:prstGeom prst="rect">
+            <a:avLst/>
+          </a:prstGeom>
+        </p:spPr>
+      </p:pic>
+      <p:sp>
+        <p:nvSpPr>
+          <p:cNvPr id="5" name="TextBox 4"/>
+          <p:cNvSpPr txBox="1"/>
+          <p:nvPr/>
+        </p:nvSpPr>
+        <p:spPr>
+          <a:xfrm>
+            <a:off x="640080" y="5989320"/>
+            <a:ext cx="10881360" cy="731520"/>
+          </a:xfrm>
+          <a:prstGeom prst="rect">
+            <a:avLst/>
+          </a:prstGeom>
+          <a:noFill/>
+        </p:spPr>
+        <p:txBody>
+          <a:bodyPr wrap="square">
+            <a:spAutoFit/>
+          </a:bodyPr>
+          <a:lstStyle/>
+          <a:p>
+            <a:pPr>
+              <a:defRPr sz="1600">
+                <a:solidFill>
+                  <a:srgbClr val="2C3E50"/>
+                </a:solidFill>
+              </a:defRPr>
+            </a:pPr>
+            <a:r>
+              <a:t>Patient-level embedding (mean pooled); colored by response</a:t>
+            </a:r>
+          </a:p>
+        </p:txBody>
+      </p:sp>
+    </p:spTree>
+  </p:cSld>
+  <p:clrMapOvr>
+    <a:masterClrMapping/>
+  </p:clrMapOvr>
+</p:sld>
+</file>
+
+<file path=ppt/slides/slide18.xml><?xml version="1.0" encoding="utf-8"?>
+<p:sld xmlns:a="http://schemas.openxmlformats.org/drawingml/2006/main" xmlns:p="http://schemas.openxmlformats.org/presentationml/2006/main" xmlns:r="http://schemas.openxmlformats.org/officeDocument/2006/relationships">
+  <p:cSld>
+    <p:spTree>
+      <p:nvGrpSpPr>
+        <p:cNvPr id="1" name=""/>
+        <p:cNvGrpSpPr/>
+        <p:nvPr/>
+      </p:nvGrpSpPr>
+      <p:grpSpPr/>
+      <p:sp>
+        <p:nvSpPr>
+          <p:cNvPr id="2" name="Rectangle 1"/>
+          <p:cNvSpPr/>
+          <p:nvPr/>
+        </p:nvSpPr>
+        <p:spPr>
+          <a:xfrm>
+            <a:off x="0" y="0"/>
+            <a:ext cx="12191695" cy="1097280"/>
+          </a:xfrm>
+          <a:prstGeom prst="rect">
+            <a:avLst/>
+          </a:prstGeom>
+          <a:solidFill>
+            <a:srgbClr val="2C3E50"/>
+          </a:solidFill>
+          <a:ln>
+            <a:noFill/>
+          </a:ln>
+        </p:spPr>
+        <p:style>
+          <a:lnRef idx="1">
+            <a:schemeClr val="accent1"/>
+          </a:lnRef>
+          <a:fillRef idx="3">
+            <a:schemeClr val="accent1"/>
+          </a:fillRef>
+          <a:effectRef idx="2">
+            <a:schemeClr val="accent1"/>
+          </a:effectRef>
+          <a:fontRef idx="minor">
+            <a:schemeClr val="lt1"/>
+          </a:fontRef>
+        </p:style>
+        <p:txBody>
+          <a:bodyPr rtlCol="0" anchor="ctr"/>
+          <a:lstStyle/>
+          <a:p>
+            <a:pPr algn="ctr"/>
+          </a:p>
+        </p:txBody>
+      </p:sp>
+      <p:sp>
+        <p:nvSpPr>
+          <p:cNvPr id="3" name="TextBox 2"/>
+          <p:cNvSpPr txBox="1"/>
+          <p:nvPr/>
+        </p:nvSpPr>
+        <p:spPr>
+          <a:xfrm>
+            <a:off x="457200" y="274320"/>
+            <a:ext cx="11247120" cy="731520"/>
+          </a:xfrm>
+          <a:prstGeom prst="rect">
+            <a:avLst/>
+          </a:prstGeom>
+          <a:noFill/>
+        </p:spPr>
+        <p:txBody>
+          <a:bodyPr wrap="none">
+            <a:spAutoFit/>
+          </a:bodyPr>
+          <a:lstStyle/>
+          <a:p>
+            <a:pPr>
+              <a:defRPr sz="3200" b="1">
+                <a:solidFill>
+                  <a:srgbClr val="FFFFFF"/>
+                </a:solidFill>
+              </a:defRPr>
+            </a:pPr>
+            <a:r>
+              <a:t>Key Findings Summary</a:t>
+            </a:r>
+          </a:p>
+        </p:txBody>
+      </p:sp>
+      <p:sp>
+        <p:nvSpPr>
+          <p:cNvPr id="4" name="TextBox 3"/>
+          <p:cNvSpPr txBox="1"/>
+          <p:nvPr/>
+        </p:nvSpPr>
+        <p:spPr>
+          <a:xfrm>
+            <a:off x="457200" y="1371600"/>
+            <a:ext cx="5303520" cy="5029200"/>
+          </a:xfrm>
+          <a:prstGeom prst="rect">
+            <a:avLst/>
+          </a:prstGeom>
+          <a:noFill/>
+        </p:spPr>
+        <p:txBody>
+          <a:bodyPr wrap="square">
+            <a:spAutoFit/>
+          </a:bodyPr>
+          <a:lstStyle/>
+          <a:p>
+            <a:pPr>
+              <a:spcBef>
+                <a:spcPts val="800"/>
+              </a:spcBef>
+              <a:defRPr sz="1800">
+                <a:solidFill>
+                  <a:srgbClr val="2C3E50"/>
+                </a:solidFill>
+              </a:defRPr>
+            </a:pPr>
+            <a:r>
+              <a:t>  Supervised MIL:</a:t>
+            </a:r>
+          </a:p>
+          <a:p>
+            <a:pPr>
+              <a:spcBef>
+                <a:spcPts val="800"/>
+              </a:spcBef>
+              <a:defRPr sz="1800">
+                <a:solidFill>
+                  <a:srgbClr val="2C3E50"/>
+                </a:solidFill>
+              </a:defRPr>
+            </a:pPr>
+            <a:r>
+              <a:t>     Mean AUC ≈ 0.754</a:t>
+            </a:r>
+          </a:p>
+          <a:p>
+            <a:pPr>
+              <a:spcBef>
+                <a:spcPts val="800"/>
+              </a:spcBef>
+              <a:defRPr sz="1800">
+                <a:solidFill>
+                  <a:srgbClr val="2C3E50"/>
+                </a:solidFill>
+              </a:defRPr>
+            </a:pPr>
+            <a:r>
+              <a:t>     Attention identifies predictive clonotypes</a:t>
+            </a:r>
+          </a:p>
+          <a:p>
+            <a:pPr>
+              <a:spcBef>
+                <a:spcPts val="800"/>
+              </a:spcBef>
+              <a:defRPr sz="1800">
+                <a:solidFill>
+                  <a:srgbClr val="2C3E50"/>
+                </a:solidFill>
+              </a:defRPr>
+            </a:pPr>
+            <a:r>
+              <a:t>  </a:t>
+            </a:r>
+          </a:p>
+          <a:p>
+            <a:pPr>
+              <a:spcBef>
+                <a:spcPts val="800"/>
+              </a:spcBef>
+              <a:defRPr sz="1800">
+                <a:solidFill>
+                  <a:srgbClr val="2C3E50"/>
+                </a:solidFill>
+              </a:defRPr>
+            </a:pPr>
+            <a:r>
+              <a:t>  Unsupervised:</a:t>
+            </a:r>
+          </a:p>
+          <a:p>
+            <a:pPr>
+              <a:spcBef>
+                <a:spcPts val="800"/>
+              </a:spcBef>
+              <a:defRPr sz="1800">
+                <a:solidFill>
+                  <a:srgbClr val="2C3E50"/>
+                </a:solidFill>
+              </a:defRPr>
+            </a:pPr>
+            <a:r>
+              <a:t>     UMAP visualizes sequence concepts</a:t>
+            </a:r>
+          </a:p>
+          <a:p>
+            <a:pPr>
+              <a:spcBef>
+                <a:spcPts val="800"/>
+              </a:spcBef>
+              <a:defRPr sz="1800">
+                <a:solidFill>
+                  <a:srgbClr val="2C3E50"/>
+                </a:solidFill>
+              </a:defRPr>
+            </a:pPr>
+            <a:r>
+              <a:t>     Patient embedding provides structural QC</a:t>
+            </a:r>
+          </a:p>
+        </p:txBody>
+      </p:sp>
+      <p:sp>
+        <p:nvSpPr>
+          <p:cNvPr id="5" name="TextBox 4"/>
+          <p:cNvSpPr txBox="1"/>
+          <p:nvPr/>
+        </p:nvSpPr>
+        <p:spPr>
+          <a:xfrm>
+            <a:off x="6217920" y="1371600"/>
+            <a:ext cx="5303520" cy="5029200"/>
+          </a:xfrm>
+          <a:prstGeom prst="rect">
+            <a:avLst/>
+          </a:prstGeom>
+          <a:noFill/>
+        </p:spPr>
+        <p:txBody>
+          <a:bodyPr wrap="square">
+            <a:spAutoFit/>
+          </a:bodyPr>
+          <a:lstStyle/>
+          <a:p>
+            <a:pPr>
+              <a:spcBef>
+                <a:spcPts val="800"/>
+              </a:spcBef>
+              <a:defRPr sz="1800">
+                <a:solidFill>
+                  <a:srgbClr val="2C3E50"/>
+                </a:solidFill>
+              </a:defRPr>
+            </a:pPr>
+            <a:r>
+              <a:t>  Clinical message:</a:t>
+            </a:r>
+          </a:p>
+          <a:p>
+            <a:pPr>
+              <a:spcBef>
+                <a:spcPts val="800"/>
+              </a:spcBef>
+              <a:defRPr sz="1800">
+                <a:solidFill>
+                  <a:srgbClr val="2C3E50"/>
+                </a:solidFill>
+              </a:defRPr>
+            </a:pPr>
+            <a:r>
+              <a:t>     Potential pre-therapy biomarker signal from TCR repertoire</a:t>
+            </a:r>
+          </a:p>
+          <a:p>
+            <a:pPr>
+              <a:spcBef>
+                <a:spcPts val="800"/>
+              </a:spcBef>
+              <a:defRPr sz="1800">
+                <a:solidFill>
+                  <a:srgbClr val="2C3E50"/>
+                </a:solidFill>
+              </a:defRPr>
+            </a:pPr>
+            <a:r>
+              <a:t>  </a:t>
+            </a:r>
+          </a:p>
+          <a:p>
+            <a:pPr>
+              <a:spcBef>
+                <a:spcPts val="800"/>
+              </a:spcBef>
+              <a:defRPr sz="1800">
+                <a:solidFill>
+                  <a:srgbClr val="2C3E50"/>
+                </a:solidFill>
+              </a:defRPr>
+            </a:pPr>
+            <a:r>
+              <a:t>  Interpretability:</a:t>
+            </a:r>
+          </a:p>
+          <a:p>
+            <a:pPr>
+              <a:spcBef>
+                <a:spcPts val="800"/>
+              </a:spcBef>
+              <a:defRPr sz="1800">
+                <a:solidFill>
+                  <a:srgbClr val="2C3E50"/>
+                </a:solidFill>
+              </a:defRPr>
+            </a:pPr>
+            <a:r>
+              <a:t>     High-attention sequences map to localized regions in sequence space</a:t>
+            </a:r>
+          </a:p>
+        </p:txBody>
+      </p:sp>
+    </p:spTree>
+  </p:cSld>
+  <p:clrMapOvr>
+    <a:masterClrMapping/>
+  </p:clrMapOvr>
+</p:sld>
+</file>
+
+<file path=ppt/slides/slide19.xml><?xml version="1.0" encoding="utf-8"?>
+<p:sld xmlns:a="http://schemas.openxmlformats.org/drawingml/2006/main" xmlns:p="http://schemas.openxmlformats.org/presentationml/2006/main" xmlns:r="http://schemas.openxmlformats.org/officeDocument/2006/relationships">
+  <p:cSld>
+    <p:spTree>
+      <p:nvGrpSpPr>
+        <p:cNvPr id="1" name=""/>
+        <p:cNvGrpSpPr/>
+        <p:nvPr/>
+      </p:nvGrpSpPr>
+      <p:grpSpPr/>
+      <p:sp>
+        <p:nvSpPr>
+          <p:cNvPr id="2" name="Rectangle 1"/>
+          <p:cNvSpPr/>
+          <p:nvPr/>
+        </p:nvSpPr>
+        <p:spPr>
+          <a:xfrm>
+            <a:off x="0" y="0"/>
+            <a:ext cx="12191695" cy="1097280"/>
+          </a:xfrm>
+          <a:prstGeom prst="rect">
+            <a:avLst/>
+          </a:prstGeom>
+          <a:solidFill>
+            <a:srgbClr val="2C3E50"/>
+          </a:solidFill>
+          <a:ln>
+            <a:noFill/>
+          </a:ln>
+        </p:spPr>
+        <p:style>
+          <a:lnRef idx="1">
+            <a:schemeClr val="accent1"/>
+          </a:lnRef>
+          <a:fillRef idx="3">
+            <a:schemeClr val="accent1"/>
+          </a:fillRef>
+          <a:effectRef idx="2">
+            <a:schemeClr val="accent1"/>
+          </a:effectRef>
+          <a:fontRef idx="minor">
+            <a:schemeClr val="lt1"/>
+          </a:fontRef>
+        </p:style>
+        <p:txBody>
+          <a:bodyPr rtlCol="0" anchor="ctr"/>
+          <a:lstStyle/>
+          <a:p>
+            <a:pPr algn="ctr"/>
+          </a:p>
+        </p:txBody>
+      </p:sp>
+      <p:sp>
+        <p:nvSpPr>
+          <p:cNvPr id="3" name="TextBox 2"/>
+          <p:cNvSpPr txBox="1"/>
+          <p:nvPr/>
+        </p:nvSpPr>
+        <p:spPr>
+          <a:xfrm>
+            <a:off x="457200" y="274320"/>
+            <a:ext cx="11247120" cy="731520"/>
+          </a:xfrm>
+          <a:prstGeom prst="rect">
+            <a:avLst/>
+          </a:prstGeom>
+          <a:noFill/>
+        </p:spPr>
+        <p:txBody>
+          <a:bodyPr wrap="none">
+            <a:spAutoFit/>
+          </a:bodyPr>
+          <a:lstStyle/>
+          <a:p>
+            <a:pPr>
+              <a:defRPr sz="3200" b="1">
+                <a:solidFill>
+                  <a:srgbClr val="FFFFFF"/>
+                </a:solidFill>
+              </a:defRPr>
+            </a:pPr>
+            <a:r>
+              <a:t>Limitations &amp; Next Steps</a:t>
+            </a:r>
+          </a:p>
+        </p:txBody>
+      </p:sp>
+      <p:sp>
+        <p:nvSpPr>
+          <p:cNvPr id="4" name="TextBox 3"/>
+          <p:cNvSpPr txBox="1"/>
+          <p:nvPr/>
+        </p:nvSpPr>
+        <p:spPr>
+          <a:xfrm>
+            <a:off x="457200" y="1371600"/>
+            <a:ext cx="11247120" cy="5029200"/>
+          </a:xfrm>
+          <a:prstGeom prst="rect">
+            <a:avLst/>
+          </a:prstGeom>
+          <a:noFill/>
+        </p:spPr>
+        <p:txBody>
+          <a:bodyPr wrap="square">
+            <a:spAutoFit/>
+          </a:bodyPr>
+          <a:lstStyle/>
+          <a:p>
+            <a:pPr>
+              <a:spcBef>
+                <a:spcPts val="1000"/>
+              </a:spcBef>
+              <a:spcAft>
+                <a:spcPts val="500"/>
+              </a:spcAft>
+              <a:defRPr sz="2000">
+                <a:solidFill>
+                  <a:srgbClr val="2C3E50"/>
+                </a:solidFill>
+              </a:defRPr>
+            </a:pPr>
+            <a:r>
+              <a:t>  Small cohort size (n=34) → needs external validation</a:t>
+            </a:r>
+          </a:p>
+          <a:p>
+            <a:pPr>
+              <a:spcBef>
+                <a:spcPts val="1000"/>
+              </a:spcBef>
+              <a:spcAft>
+                <a:spcPts val="500"/>
+              </a:spcAft>
+              <a:defRPr sz="2000">
+                <a:solidFill>
+                  <a:srgbClr val="2C3E50"/>
+                </a:solidFill>
+              </a:defRPr>
+            </a:pPr>
+            <a:r>
+              <a:t>  No HLA available (unlike Sidhom 2022 TCR+HLA models)</a:t>
+            </a:r>
+          </a:p>
+          <a:p>
+            <a:pPr>
+              <a:spcBef>
+                <a:spcPts val="1000"/>
+              </a:spcBef>
+              <a:spcAft>
+                <a:spcPts val="500"/>
+              </a:spcAft>
+              <a:defRPr sz="2000">
+                <a:solidFill>
+                  <a:srgbClr val="2C3E50"/>
+                </a:solidFill>
+              </a:defRPr>
+            </a:pPr>
+            <a:r>
+              <a:t>  Improve: add more patients, integrate clinical covariates, prospective evaluation</a:t>
+            </a:r>
+          </a:p>
+          <a:p>
+            <a:pPr>
+              <a:spcBef>
+                <a:spcPts val="1000"/>
+              </a:spcBef>
+              <a:spcAft>
+                <a:spcPts val="500"/>
+              </a:spcAft>
+              <a:defRPr sz="2000">
+                <a:solidFill>
+                  <a:srgbClr val="2C3E50"/>
+                </a:solidFill>
+              </a:defRPr>
+            </a:pPr>
+            <a:r>
+              <a:t>  Biology: validate high-attention clonotypes and motifs experimentally</a:t>
             </a:r>
           </a:p>
         </p:txBody>
@@ -4681,7 +5205,7 @@
               </a:defRPr>
             </a:pPr>
             <a:r>
-              <a:t>  Immunotherapy revolutionizes cancer treatment</a:t>
+              <a:t>  CD19 CAR T-cell therapy improves rrLBCL outcomes, but many patients relapse or fail to respond</a:t>
             </a:r>
           </a:p>
           <a:p>
@@ -4699,7 +5223,7 @@
               </a:defRPr>
             </a:pPr>
             <a:r>
-              <a:t>  Challenge: Only 20-40% of patients respond</a:t>
+              <a:t>  Goal: predict response before therapy using only TCR repertoire features (CDR3 + V/J)</a:t>
             </a:r>
           </a:p>
           <a:p>
@@ -4717,7 +5241,7 @@
               </a:defRPr>
             </a:pPr>
             <a:r>
-              <a:t>  Hypothesis: TCR repertoire predicts response</a:t>
+              <a:t>  Approach: DeepTCR supervised multiple instance learning (MIL) with attention</a:t>
             </a:r>
           </a:p>
           <a:p>
@@ -4735,7 +5259,7 @@
               </a:defRPr>
             </a:pPr>
             <a:r>
-              <a:t>  Objective: Develop predictive model using DeepTCR</a:t>
+              <a:t>  Add-on: unsupervised embeddings + UMAP to visualize sequence concepts (Sidhom-style adapted)</a:t>
             </a:r>
           </a:p>
           <a:p>
@@ -4753,7 +5277,143 @@
               </a:defRPr>
             </a:pPr>
             <a:r>
-              <a:t>  Application: Basal Cell Carcinoma (BCC) patients</a:t>
+              <a:t>  Outcome: interpretable model + candidate predictive clonotypes</a:t>
+            </a:r>
+          </a:p>
+        </p:txBody>
+      </p:sp>
+    </p:spTree>
+  </p:cSld>
+  <p:clrMapOvr>
+    <a:masterClrMapping/>
+  </p:clrMapOvr>
+</p:sld>
+</file>
+
+<file path=ppt/slides/slide20.xml><?xml version="1.0" encoding="utf-8"?>
+<p:sld xmlns:a="http://schemas.openxmlformats.org/drawingml/2006/main" xmlns:p="http://schemas.openxmlformats.org/presentationml/2006/main" xmlns:r="http://schemas.openxmlformats.org/officeDocument/2006/relationships">
+  <p:cSld>
+    <p:spTree>
+      <p:nvGrpSpPr>
+        <p:cNvPr id="1" name=""/>
+        <p:cNvGrpSpPr/>
+        <p:nvPr/>
+      </p:nvGrpSpPr>
+      <p:grpSpPr/>
+      <p:sp>
+        <p:nvSpPr>
+          <p:cNvPr id="2" name="Rectangle 1"/>
+          <p:cNvSpPr/>
+          <p:nvPr/>
+        </p:nvSpPr>
+        <p:spPr>
+          <a:xfrm>
+            <a:off x="0" y="0"/>
+            <a:ext cx="12191695" cy="6858000"/>
+          </a:xfrm>
+          <a:prstGeom prst="rect">
+            <a:avLst/>
+          </a:prstGeom>
+          <a:solidFill>
+            <a:srgbClr val="2C3E50"/>
+          </a:solidFill>
+          <a:ln>
+            <a:noFill/>
+          </a:ln>
+        </p:spPr>
+        <p:style>
+          <a:lnRef idx="1">
+            <a:schemeClr val="accent1"/>
+          </a:lnRef>
+          <a:fillRef idx="3">
+            <a:schemeClr val="accent1"/>
+          </a:fillRef>
+          <a:effectRef idx="2">
+            <a:schemeClr val="accent1"/>
+          </a:effectRef>
+          <a:fontRef idx="minor">
+            <a:schemeClr val="lt1"/>
+          </a:fontRef>
+        </p:style>
+        <p:txBody>
+          <a:bodyPr rtlCol="0" anchor="ctr"/>
+          <a:lstStyle/>
+          <a:p>
+            <a:pPr algn="ctr"/>
+          </a:p>
+        </p:txBody>
+      </p:sp>
+      <p:sp>
+        <p:nvSpPr>
+          <p:cNvPr id="3" name="TextBox 2"/>
+          <p:cNvSpPr txBox="1"/>
+          <p:nvPr/>
+        </p:nvSpPr>
+        <p:spPr>
+          <a:xfrm>
+            <a:off x="457200" y="2286000"/>
+            <a:ext cx="11247120" cy="1371600"/>
+          </a:xfrm>
+          <a:prstGeom prst="rect">
+            <a:avLst/>
+          </a:prstGeom>
+          <a:noFill/>
+        </p:spPr>
+        <p:txBody>
+          <a:bodyPr wrap="none">
+            <a:spAutoFit/>
+          </a:bodyPr>
+          <a:lstStyle/>
+          <a:p>
+            <a:pPr algn="ctr">
+              <a:defRPr sz="4400" b="1">
+                <a:solidFill>
+                  <a:srgbClr val="FFFFFF"/>
+                </a:solidFill>
+              </a:defRPr>
+            </a:pPr>
+            <a:r>
+              <a:t>Thank You</a:t>
+            </a:r>
+          </a:p>
+        </p:txBody>
+      </p:sp>
+      <p:sp>
+        <p:nvSpPr>
+          <p:cNvPr id="4" name="TextBox 3"/>
+          <p:cNvSpPr txBox="1"/>
+          <p:nvPr/>
+        </p:nvSpPr>
+        <p:spPr>
+          <a:xfrm>
+            <a:off x="457200" y="3840480"/>
+            <a:ext cx="11247120" cy="914400"/>
+          </a:xfrm>
+          <a:prstGeom prst="rect">
+            <a:avLst/>
+          </a:prstGeom>
+          <a:noFill/>
+        </p:spPr>
+        <p:txBody>
+          <a:bodyPr wrap="none">
+            <a:spAutoFit/>
+          </a:bodyPr>
+          <a:lstStyle/>
+          <a:p>
+            <a:pPr algn="ctr">
+              <a:defRPr sz="2400">
+                <a:solidFill>
+                  <a:srgbClr val="FFFFFF"/>
+                </a:solidFill>
+              </a:defRPr>
+            </a:pPr>
+            <a:r>
+              <a:t>Questions?</a:t>
+            </a:r>
+            <a:br/>
+            <a:br/>
+            <a:r>
+              <a:t>DeepTCR supervised MIL + unsupervised visualization</a:t>
             </a:r>
           </a:p>
         </p:txBody>
@@ -4902,7 +5562,7 @@
               </a:defRPr>
             </a:pPr>
             <a:r>
-              <a:t>     153 total patients</a:t>
+              <a:t>     34 total patients</a:t>
             </a:r>
           </a:p>
           <a:p>
@@ -4917,7 +5577,7 @@
               </a:defRPr>
             </a:pPr>
             <a:r>
-              <a:t>     77 responders (50.3%)</a:t>
+              <a:t>     18 responders</a:t>
             </a:r>
           </a:p>
           <a:p>
@@ -4932,7 +5592,7 @@
               </a:defRPr>
             </a:pPr>
             <a:r>
-              <a:t>     76 non-responders (49.7%)</a:t>
+              <a:t>     16 non-responders</a:t>
             </a:r>
           </a:p>
           <a:p>
@@ -4962,7 +5622,7 @@
               </a:defRPr>
             </a:pPr>
             <a:r>
-              <a:t>  Treatment:</a:t>
+              <a:t>  Therapy context:</a:t>
             </a:r>
           </a:p>
           <a:p>
@@ -4977,9 +5637,32 @@
               </a:defRPr>
             </a:pPr>
             <a:r>
-              <a:t>     Anti-PD-1 or Anti-CTLA-4</a:t>
-            </a:r>
-          </a:p>
+              <a:t>     CD19 CAR T-cell therapy (rrLBCL)</a:t>
+            </a:r>
+          </a:p>
+        </p:txBody>
+      </p:sp>
+      <p:sp>
+        <p:nvSpPr>
+          <p:cNvPr id="5" name="TextBox 4"/>
+          <p:cNvSpPr txBox="1"/>
+          <p:nvPr/>
+        </p:nvSpPr>
+        <p:spPr>
+          <a:xfrm>
+            <a:off x="6217920" y="1371600"/>
+            <a:ext cx="5303520" cy="5029200"/>
+          </a:xfrm>
+          <a:prstGeom prst="rect">
+            <a:avLst/>
+          </a:prstGeom>
+          <a:noFill/>
+        </p:spPr>
+        <p:txBody>
+          <a:bodyPr wrap="square">
+            <a:spAutoFit/>
+          </a:bodyPr>
+          <a:lstStyle/>
           <a:p>
             <a:pPr>
               <a:spcBef>
@@ -4992,32 +5675,9 @@
               </a:defRPr>
             </a:pPr>
             <a:r>
-              <a:t>     Checkpoint blockade therapy</a:t>
-            </a:r>
-          </a:p>
-        </p:txBody>
-      </p:sp>
-      <p:sp>
-        <p:nvSpPr>
-          <p:cNvPr id="5" name="TextBox 4"/>
-          <p:cNvSpPr txBox="1"/>
-          <p:nvPr/>
-        </p:nvSpPr>
-        <p:spPr>
-          <a:xfrm>
-            <a:off x="6217920" y="1371600"/>
-            <a:ext cx="5303520" cy="5029200"/>
-          </a:xfrm>
-          <a:prstGeom prst="rect">
-            <a:avLst/>
-          </a:prstGeom>
-          <a:noFill/>
-        </p:spPr>
-        <p:txBody>
-          <a:bodyPr wrap="square">
-            <a:spAutoFit/>
-          </a:bodyPr>
-          <a:lstStyle/>
+              <a:t>  TCR Sequences:</a:t>
+            </a:r>
+          </a:p>
           <a:p>
             <a:pPr>
               <a:spcBef>
@@ -5030,22 +5690,7 @@
               </a:defRPr>
             </a:pPr>
             <a:r>
-              <a:t>  TCR Sequences:</a:t>
-            </a:r>
-          </a:p>
-          <a:p>
-            <a:pPr>
-              <a:spcBef>
-                <a:spcPts val="800"/>
-              </a:spcBef>
-              <a:defRPr sz="1800">
-                <a:solidFill>
-                  <a:srgbClr val="2C3E50"/>
-                </a:solidFill>
-              </a:defRPr>
-            </a:pPr>
-            <a:r>
-              <a:t>     239,634 total sequences</a:t>
+              <a:t>     239,637 total sequences</a:t>
             </a:r>
           </a:p>
           <a:p>
@@ -5167,7 +5812,7 @@
         <p:spPr>
           <a:xfrm>
             <a:off x="0" y="0"/>
-            <a:ext cx="12191695" cy="1097280"/>
+            <a:ext cx="12191695" cy="1005840"/>
           </a:xfrm>
           <a:prstGeom prst="rect">
             <a:avLst/>
@@ -5209,7 +5854,7 @@
         </p:nvSpPr>
         <p:spPr>
           <a:xfrm>
-            <a:off x="457200" y="274320"/>
+            <a:off x="457200" y="228600"/>
             <a:ext cx="11247120" cy="731520"/>
           </a:xfrm>
           <a:prstGeom prst="rect">
@@ -5224,152 +5869,21 @@
           <a:lstStyle/>
           <a:p>
             <a:pPr>
-              <a:defRPr sz="3200" b="1">
+              <a:defRPr sz="3000" b="1">
                 <a:solidFill>
                   <a:srgbClr val="FFFFFF"/>
                 </a:solidFill>
               </a:defRPr>
             </a:pPr>
             <a:r>
-              <a:t>DeepTCR Architecture</a:t>
-            </a:r>
-          </a:p>
-        </p:txBody>
-      </p:sp>
-      <p:sp>
-        <p:nvSpPr>
-          <p:cNvPr id="4" name="TextBox 3"/>
-          <p:cNvSpPr txBox="1"/>
-          <p:nvPr/>
-        </p:nvSpPr>
-        <p:spPr>
-          <a:xfrm>
-            <a:off x="457200" y="1371600"/>
-            <a:ext cx="5029200" cy="5029200"/>
-          </a:xfrm>
-          <a:prstGeom prst="rect">
-            <a:avLst/>
-          </a:prstGeom>
-          <a:noFill/>
-        </p:spPr>
-        <p:txBody>
-          <a:bodyPr wrap="square">
-            <a:spAutoFit/>
-          </a:bodyPr>
-          <a:lstStyle/>
-          <a:p>
-            <a:pPr>
-              <a:spcBef>
-                <a:spcPts val="1000"/>
-              </a:spcBef>
-              <a:spcAft>
-                <a:spcPts val="500"/>
-              </a:spcAft>
-              <a:defRPr sz="2000">
-                <a:solidFill>
-                  <a:srgbClr val="2C3E50"/>
-                </a:solidFill>
-              </a:defRPr>
-            </a:pPr>
-            <a:r>
-              <a:t>  Multiple Instance Learning (MIL) approach</a:t>
-            </a:r>
-          </a:p>
-          <a:p>
-            <a:pPr>
-              <a:spcBef>
-                <a:spcPts val="1000"/>
-              </a:spcBef>
-              <a:spcAft>
-                <a:spcPts val="500"/>
-              </a:spcAft>
-              <a:defRPr sz="2000">
-                <a:solidFill>
-                  <a:srgbClr val="2C3E50"/>
-                </a:solidFill>
-              </a:defRPr>
-            </a:pPr>
-            <a:r>
-              <a:t>  CNN-based sequence embedding (128-dim)</a:t>
-            </a:r>
-          </a:p>
-          <a:p>
-            <a:pPr>
-              <a:spcBef>
-                <a:spcPts val="1000"/>
-              </a:spcBef>
-              <a:spcAft>
-                <a:spcPts val="500"/>
-              </a:spcAft>
-              <a:defRPr sz="2000">
-                <a:solidFill>
-                  <a:srgbClr val="2C3E50"/>
-                </a:solidFill>
-              </a:defRPr>
-            </a:pPr>
-            <a:r>
-              <a:t>  Attention mechanism (64 concepts)</a:t>
-            </a:r>
-          </a:p>
-          <a:p>
-            <a:pPr>
-              <a:spcBef>
-                <a:spcPts val="1000"/>
-              </a:spcBef>
-              <a:spcAft>
-                <a:spcPts val="500"/>
-              </a:spcAft>
-              <a:defRPr sz="2000">
-                <a:solidFill>
-                  <a:srgbClr val="2C3E50"/>
-                </a:solidFill>
-              </a:defRPr>
-            </a:pPr>
-            <a:r>
-              <a:t>  Identifies predictive sequences within repertoire</a:t>
-            </a:r>
-          </a:p>
-          <a:p>
-            <a:pPr>
-              <a:spcBef>
-                <a:spcPts val="1000"/>
-              </a:spcBef>
-              <a:spcAft>
-                <a:spcPts val="500"/>
-              </a:spcAft>
-              <a:defRPr sz="2000">
-                <a:solidFill>
-                  <a:srgbClr val="2C3E50"/>
-                </a:solidFill>
-              </a:defRPr>
-            </a:pPr>
-            <a:r>
-              <a:t>  Weighted aggregation patient representation</a:t>
-            </a:r>
-          </a:p>
-          <a:p>
-            <a:pPr>
-              <a:spcBef>
-                <a:spcPts val="1000"/>
-              </a:spcBef>
-              <a:spcAft>
-                <a:spcPts val="500"/>
-              </a:spcAft>
-              <a:defRPr sz="2000">
-                <a:solidFill>
-                  <a:srgbClr val="2C3E50"/>
-                </a:solidFill>
-              </a:defRPr>
-            </a:pPr>
-            <a:r>
-              <a:t>  Binary classification: Responder vs Non-Responder</a:t>
+              <a:t>Figure 1: Data Processing Pipeline</a:t>
             </a:r>
           </a:p>
         </p:txBody>
       </p:sp>
       <p:pic>
         <p:nvPicPr>
-          <p:cNvPr id="5" name="Picture 4" descr="figure2_architecture.png"/>
+          <p:cNvPr id="4" name="Picture 3" descr="figure1_pipeline.png"/>
           <p:cNvPicPr>
             <a:picLocks noChangeAspect="1"/>
           </p:cNvPicPr>
@@ -5383,14 +5897,49 @@
         </p:blipFill>
         <p:spPr>
           <a:xfrm>
-            <a:off x="5943600" y="1371600"/>
-            <a:ext cx="5760720" cy="2859638"/>
+            <a:off x="640080" y="1234440"/>
+            <a:ext cx="10881360" cy="3835875"/>
           </a:xfrm>
           <a:prstGeom prst="rect">
             <a:avLst/>
           </a:prstGeom>
         </p:spPr>
       </p:pic>
+      <p:sp>
+        <p:nvSpPr>
+          <p:cNvPr id="5" name="TextBox 4"/>
+          <p:cNvSpPr txBox="1"/>
+          <p:nvPr/>
+        </p:nvSpPr>
+        <p:spPr>
+          <a:xfrm>
+            <a:off x="640080" y="5989320"/>
+            <a:ext cx="10881360" cy="731520"/>
+          </a:xfrm>
+          <a:prstGeom prst="rect">
+            <a:avLst/>
+          </a:prstGeom>
+          <a:noFill/>
+        </p:spPr>
+        <p:txBody>
+          <a:bodyPr wrap="square">
+            <a:spAutoFit/>
+          </a:bodyPr>
+          <a:lstStyle/>
+          <a:p>
+            <a:pPr>
+              <a:defRPr sz="1600">
+                <a:solidFill>
+                  <a:srgbClr val="2C3E50"/>
+                </a:solidFill>
+              </a:defRPr>
+            </a:pPr>
+            <a:r>
+              <a:t>From raw TCR sequencing → TRB extraction → encoding → DeepTCR training → response prediction</a:t>
+            </a:r>
+          </a:p>
+        </p:txBody>
+      </p:sp>
     </p:spTree>
   </p:cSld>
   <p:clrMapOvr>
@@ -5418,7 +5967,7 @@
         <p:spPr>
           <a:xfrm>
             <a:off x="0" y="0"/>
-            <a:ext cx="12191695" cy="1097280"/>
+            <a:ext cx="12191695" cy="1005840"/>
           </a:xfrm>
           <a:prstGeom prst="rect">
             <a:avLst/>
@@ -5460,7 +6009,7 @@
         </p:nvSpPr>
         <p:spPr>
           <a:xfrm>
-            <a:off x="457200" y="274320"/>
+            <a:off x="457200" y="228600"/>
             <a:ext cx="11247120" cy="731520"/>
           </a:xfrm>
           <a:prstGeom prst="rect">
@@ -5475,28 +6024,52 @@
           <a:lstStyle/>
           <a:p>
             <a:pPr>
-              <a:defRPr sz="3200" b="1">
+              <a:defRPr sz="3000" b="1">
                 <a:solidFill>
                   <a:srgbClr val="FFFFFF"/>
                 </a:solidFill>
               </a:defRPr>
             </a:pPr>
             <a:r>
-              <a:t>Monte Carlo Cross-Validation</a:t>
-            </a:r>
-          </a:p>
-        </p:txBody>
-      </p:sp>
-      <p:sp>
-        <p:nvSpPr>
-          <p:cNvPr id="4" name="TextBox 3"/>
+              <a:t>Unsupervised Learning Pipeline (Overview)</a:t>
+            </a:r>
+          </a:p>
+        </p:txBody>
+      </p:sp>
+      <p:pic>
+        <p:nvPicPr>
+          <p:cNvPr id="4" name="Picture 3" descr="figureS14_unsupervised_pipeline_blocks.png"/>
+          <p:cNvPicPr>
+            <a:picLocks noChangeAspect="1"/>
+          </p:cNvPicPr>
+          <p:nvPr/>
+        </p:nvPicPr>
+        <p:blipFill>
+          <a:blip r:embed="rId2"/>
+          <a:stretch>
+            <a:fillRect/>
+          </a:stretch>
+        </p:blipFill>
+        <p:spPr>
+          <a:xfrm>
+            <a:off x="640080" y="1234440"/>
+            <a:ext cx="10881360" cy="2720340"/>
+          </a:xfrm>
+          <a:prstGeom prst="rect">
+            <a:avLst/>
+          </a:prstGeom>
+        </p:spPr>
+      </p:pic>
+      <p:sp>
+        <p:nvSpPr>
+          <p:cNvPr id="5" name="TextBox 4"/>
           <p:cNvSpPr txBox="1"/>
           <p:nvPr/>
         </p:nvSpPr>
         <p:spPr>
           <a:xfrm>
-            <a:off x="457200" y="1371600"/>
-            <a:ext cx="11247120" cy="5029200"/>
+            <a:off x="640080" y="5989320"/>
+            <a:ext cx="10881360" cy="731520"/>
           </a:xfrm>
           <a:prstGeom prst="rect">
             <a:avLst/>
@@ -5510,110 +6083,14 @@
           <a:lstStyle/>
           <a:p>
             <a:pPr>
-              <a:spcBef>
-                <a:spcPts val="1000"/>
-              </a:spcBef>
-              <a:spcAft>
-                <a:spcPts val="500"/>
-              </a:spcAft>
-              <a:defRPr sz="2000">
+              <a:defRPr sz="1600">
                 <a:solidFill>
                   <a:srgbClr val="2C3E50"/>
                 </a:solidFill>
               </a:defRPr>
             </a:pPr>
             <a:r>
-              <a:t>  100-fold Monte Carlo Cross-Validation</a:t>
-            </a:r>
-          </a:p>
-          <a:p>
-            <a:pPr>
-              <a:spcBef>
-                <a:spcPts val="1000"/>
-              </a:spcBef>
-              <a:spcAft>
-                <a:spcPts val="500"/>
-              </a:spcAft>
-              <a:defRPr sz="2000">
-                <a:solidFill>
-                  <a:srgbClr val="2C3E50"/>
-                </a:solidFill>
-              </a:defRPr>
-            </a:pPr>
-            <a:r>
-              <a:t>  Each fold: 75% train, 25% test</a:t>
-            </a:r>
-          </a:p>
-          <a:p>
-            <a:pPr>
-              <a:spcBef>
-                <a:spcPts val="1000"/>
-              </a:spcBef>
-              <a:spcAft>
-                <a:spcPts val="500"/>
-              </a:spcAft>
-              <a:defRPr sz="2000">
-                <a:solidFill>
-                  <a:srgbClr val="2C3E50"/>
-                </a:solidFill>
-              </a:defRPr>
-            </a:pPr>
-            <a:r>
-              <a:t>  Random patient-level splits</a:t>
-            </a:r>
-          </a:p>
-          <a:p>
-            <a:pPr>
-              <a:spcBef>
-                <a:spcPts val="1000"/>
-              </a:spcBef>
-              <a:spcAft>
-                <a:spcPts val="500"/>
-              </a:spcAft>
-              <a:defRPr sz="2000">
-                <a:solidFill>
-                  <a:srgbClr val="2C3E50"/>
-                </a:solidFill>
-              </a:defRPr>
-            </a:pPr>
-            <a:r>
-              <a:t>  Prevents overfitting to specific splits</a:t>
-            </a:r>
-          </a:p>
-          <a:p>
-            <a:pPr>
-              <a:spcBef>
-                <a:spcPts val="1000"/>
-              </a:spcBef>
-              <a:spcAft>
-                <a:spcPts val="500"/>
-              </a:spcAft>
-              <a:defRPr sz="2000">
-                <a:solidFill>
-                  <a:srgbClr val="2C3E50"/>
-                </a:solidFill>
-              </a:defRPr>
-            </a:pPr>
-            <a:r>
-              <a:t>  Robust performance estimation</a:t>
-            </a:r>
-          </a:p>
-          <a:p>
-            <a:pPr>
-              <a:spcBef>
-                <a:spcPts val="1000"/>
-              </a:spcBef>
-              <a:spcAft>
-                <a:spcPts val="500"/>
-              </a:spcAft>
-              <a:defRPr sz="2000">
-                <a:solidFill>
-                  <a:srgbClr val="2C3E50"/>
-                </a:solidFill>
-              </a:defRPr>
-            </a:pPr>
-            <a:r>
-              <a:t>  Training time: ~35 minutes (H100 GPU)</a:t>
+              <a:t>Unsupervised embedding learns structure without labels; labels are used only for plot coloring/interpretation</a:t>
             </a:r>
           </a:p>
         </p:txBody>
@@ -5645,7 +6122,7 @@
         <p:spPr>
           <a:xfrm>
             <a:off x="0" y="0"/>
-            <a:ext cx="12191695" cy="1097280"/>
+            <a:ext cx="12191695" cy="1005840"/>
           </a:xfrm>
           <a:prstGeom prst="rect">
             <a:avLst/>
@@ -5687,7 +6164,7 @@
         </p:nvSpPr>
         <p:spPr>
           <a:xfrm>
-            <a:off x="457200" y="274320"/>
+            <a:off x="457200" y="228600"/>
             <a:ext cx="11247120" cy="731520"/>
           </a:xfrm>
           <a:prstGeom prst="rect">
@@ -5702,152 +6179,21 @@
           <a:lstStyle/>
           <a:p>
             <a:pPr>
-              <a:defRPr sz="3200" b="1">
+              <a:defRPr sz="3000" b="1">
                 <a:solidFill>
                   <a:srgbClr val="FFFFFF"/>
                 </a:solidFill>
               </a:defRPr>
             </a:pPr>
             <a:r>
-              <a:t>Model Performance Results</a:t>
-            </a:r>
-          </a:p>
-        </p:txBody>
-      </p:sp>
-      <p:sp>
-        <p:nvSpPr>
-          <p:cNvPr id="4" name="TextBox 3"/>
-          <p:cNvSpPr txBox="1"/>
-          <p:nvPr/>
-        </p:nvSpPr>
-        <p:spPr>
-          <a:xfrm>
-            <a:off x="457200" y="1371600"/>
-            <a:ext cx="5029200" cy="5029200"/>
-          </a:xfrm>
-          <a:prstGeom prst="rect">
-            <a:avLst/>
-          </a:prstGeom>
-          <a:noFill/>
-        </p:spPr>
-        <p:txBody>
-          <a:bodyPr wrap="square">
-            <a:spAutoFit/>
-          </a:bodyPr>
-          <a:lstStyle/>
-          <a:p>
-            <a:pPr>
-              <a:spcBef>
-                <a:spcPts val="1000"/>
-              </a:spcBef>
-              <a:spcAft>
-                <a:spcPts val="500"/>
-              </a:spcAft>
-              <a:defRPr sz="2000">
-                <a:solidFill>
-                  <a:srgbClr val="2C3E50"/>
-                </a:solidFill>
-              </a:defRPr>
-            </a:pPr>
-            <a:r>
-              <a:t>  Mean AUC: 0.754 +/- 0.035</a:t>
-            </a:r>
-          </a:p>
-          <a:p>
-            <a:pPr>
-              <a:spcBef>
-                <a:spcPts val="1000"/>
-              </a:spcBef>
-              <a:spcAft>
-                <a:spcPts val="500"/>
-              </a:spcAft>
-              <a:defRPr sz="2000">
-                <a:solidFill>
-                  <a:srgbClr val="2C3E50"/>
-                </a:solidFill>
-              </a:defRPr>
-            </a:pPr>
-            <a:r>
-              <a:t>  95% Confidence Interval: [0.747, 0.761]</a:t>
-            </a:r>
-          </a:p>
-          <a:p>
-            <a:pPr>
-              <a:spcBef>
-                <a:spcPts val="1000"/>
-              </a:spcBef>
-              <a:spcAft>
-                <a:spcPts val="500"/>
-              </a:spcAft>
-              <a:defRPr sz="2000">
-                <a:solidFill>
-                  <a:srgbClr val="2C3E50"/>
-                </a:solidFill>
-              </a:defRPr>
-            </a:pPr>
-            <a:r>
-              <a:t>  AUC Range: 0.758 - 0.788</a:t>
-            </a:r>
-          </a:p>
-          <a:p>
-            <a:pPr>
-              <a:spcBef>
-                <a:spcPts val="1000"/>
-              </a:spcBef>
-              <a:spcAft>
-                <a:spcPts val="500"/>
-              </a:spcAft>
-              <a:defRPr sz="2000">
-                <a:solidFill>
-                  <a:srgbClr val="2C3E50"/>
-                </a:solidFill>
-              </a:defRPr>
-            </a:pPr>
-            <a:r>
-              <a:t>  Consistent performance across 100 folds</a:t>
-            </a:r>
-          </a:p>
-          <a:p>
-            <a:pPr>
-              <a:spcBef>
-                <a:spcPts val="1000"/>
-              </a:spcBef>
-              <a:spcAft>
-                <a:spcPts val="500"/>
-              </a:spcAft>
-              <a:defRPr sz="2000">
-                <a:solidFill>
-                  <a:srgbClr val="2C3E50"/>
-                </a:solidFill>
-              </a:defRPr>
-            </a:pPr>
-            <a:r>
-              <a:t>  Significantly better than random (0.5)</a:t>
-            </a:r>
-          </a:p>
-          <a:p>
-            <a:pPr>
-              <a:spcBef>
-                <a:spcPts val="1000"/>
-              </a:spcBef>
-              <a:spcAft>
-                <a:spcPts val="500"/>
-              </a:spcAft>
-              <a:defRPr sz="2000">
-                <a:solidFill>
-                  <a:srgbClr val="2C3E50"/>
-                </a:solidFill>
-              </a:defRPr>
-            </a:pPr>
-            <a:r>
-              <a:t>  Good discriminative ability for clinical use</a:t>
+              <a:t>Featurization: Unsupervised vs Supervised (Schematics)</a:t>
             </a:r>
           </a:p>
         </p:txBody>
       </p:sp>
       <p:pic>
         <p:nvPicPr>
-          <p:cNvPr id="5" name="Picture 4" descr="figure4_model_performance.png"/>
+          <p:cNvPr id="4" name="Picture 3" descr="figureS12_featurization_schematics.png"/>
           <p:cNvPicPr>
             <a:picLocks noChangeAspect="1"/>
           </p:cNvPicPr>
@@ -5861,14 +6207,49 @@
         </p:blipFill>
         <p:spPr>
           <a:xfrm>
-            <a:off x="5943600" y="1371600"/>
-            <a:ext cx="5760720" cy="2458824"/>
+            <a:off x="640080" y="1234440"/>
+            <a:ext cx="10881360" cy="8078296"/>
           </a:xfrm>
           <a:prstGeom prst="rect">
             <a:avLst/>
           </a:prstGeom>
         </p:spPr>
       </p:pic>
+      <p:sp>
+        <p:nvSpPr>
+          <p:cNvPr id="5" name="TextBox 4"/>
+          <p:cNvSpPr txBox="1"/>
+          <p:nvPr/>
+        </p:nvSpPr>
+        <p:spPr>
+          <a:xfrm>
+            <a:off x="640080" y="5989320"/>
+            <a:ext cx="10881360" cy="731520"/>
+          </a:xfrm>
+          <a:prstGeom prst="rect">
+            <a:avLst/>
+          </a:prstGeom>
+          <a:noFill/>
+        </p:spPr>
+        <p:txBody>
+          <a:bodyPr wrap="square">
+            <a:spAutoFit/>
+          </a:bodyPr>
+          <a:lstStyle/>
+          <a:p>
+            <a:pPr>
+              <a:defRPr sz="1600">
+                <a:solidFill>
+                  <a:srgbClr val="2C3E50"/>
+                </a:solidFill>
+              </a:defRPr>
+            </a:pPr>
+            <a:r>
+              <a:t>Connects: input → featurization → embedding → (UMAP) and MIL attention → patient prediction</a:t>
+            </a:r>
+          </a:p>
+        </p:txBody>
+      </p:sp>
     </p:spTree>
   </p:cSld>
   <p:clrMapOvr>
@@ -5896,7 +6277,7 @@
         <p:spPr>
           <a:xfrm>
             <a:off x="0" y="0"/>
-            <a:ext cx="12191695" cy="1097280"/>
+            <a:ext cx="12191695" cy="1005840"/>
           </a:xfrm>
           <a:prstGeom prst="rect">
             <a:avLst/>
@@ -5938,7 +6319,7 @@
         </p:nvSpPr>
         <p:spPr>
           <a:xfrm>
-            <a:off x="457200" y="274320"/>
+            <a:off x="457200" y="228600"/>
             <a:ext cx="11247120" cy="731520"/>
           </a:xfrm>
           <a:prstGeom prst="rect">
@@ -5953,152 +6334,21 @@
           <a:lstStyle/>
           <a:p>
             <a:pPr>
-              <a:defRPr sz="3200" b="1">
+              <a:defRPr sz="3000" b="1">
                 <a:solidFill>
                   <a:srgbClr val="FFFFFF"/>
                 </a:solidFill>
               </a:defRPr>
             </a:pPr>
             <a:r>
-              <a:t>Attention Weight Analysis</a:t>
-            </a:r>
-          </a:p>
-        </p:txBody>
-      </p:sp>
-      <p:sp>
-        <p:nvSpPr>
-          <p:cNvPr id="4" name="TextBox 3"/>
-          <p:cNvSpPr txBox="1"/>
-          <p:nvPr/>
-        </p:nvSpPr>
-        <p:spPr>
-          <a:xfrm>
-            <a:off x="457200" y="1371600"/>
-            <a:ext cx="5029200" cy="5029200"/>
-          </a:xfrm>
-          <a:prstGeom prst="rect">
-            <a:avLst/>
-          </a:prstGeom>
-          <a:noFill/>
-        </p:spPr>
-        <p:txBody>
-          <a:bodyPr wrap="square">
-            <a:spAutoFit/>
-          </a:bodyPr>
-          <a:lstStyle/>
-          <a:p>
-            <a:pPr>
-              <a:spcBef>
-                <a:spcPts val="1000"/>
-              </a:spcBef>
-              <a:spcAft>
-                <a:spcPts val="500"/>
-              </a:spcAft>
-              <a:defRPr sz="2000">
-                <a:solidFill>
-                  <a:srgbClr val="2C3E50"/>
-                </a:solidFill>
-              </a:defRPr>
-            </a:pPr>
-            <a:r>
-              <a:t>  Attention identifies predictive sequences</a:t>
-            </a:r>
-          </a:p>
-          <a:p>
-            <a:pPr>
-              <a:spcBef>
-                <a:spcPts val="1000"/>
-              </a:spcBef>
-              <a:spcAft>
-                <a:spcPts val="500"/>
-              </a:spcAft>
-              <a:defRPr sz="2000">
-                <a:solidFill>
-                  <a:srgbClr val="2C3E50"/>
-                </a:solidFill>
-              </a:defRPr>
-            </a:pPr>
-            <a:r>
-              <a:t>  ~1% of sequences receive high attention</a:t>
-            </a:r>
-          </a:p>
-          <a:p>
-            <a:pPr>
-              <a:spcBef>
-                <a:spcPts val="1000"/>
-              </a:spcBef>
-              <a:spcAft>
-                <a:spcPts val="500"/>
-              </a:spcAft>
-              <a:defRPr sz="2000">
-                <a:solidFill>
-                  <a:srgbClr val="2C3E50"/>
-                </a:solidFill>
-              </a:defRPr>
-            </a:pPr>
-            <a:r>
-              <a:t>  Sparse attention pattern</a:t>
-            </a:r>
-          </a:p>
-          <a:p>
-            <a:pPr>
-              <a:spcBef>
-                <a:spcPts val="1000"/>
-              </a:spcBef>
-              <a:spcAft>
-                <a:spcPts val="500"/>
-              </a:spcAft>
-              <a:defRPr sz="2000">
-                <a:solidFill>
-                  <a:srgbClr val="2C3E50"/>
-                </a:solidFill>
-              </a:defRPr>
-            </a:pPr>
-            <a:r>
-              <a:t>  Consistent across responders/non-responders</a:t>
-            </a:r>
-          </a:p>
-          <a:p>
-            <a:pPr>
-              <a:spcBef>
-                <a:spcPts val="1000"/>
-              </a:spcBef>
-              <a:spcAft>
-                <a:spcPts val="500"/>
-              </a:spcAft>
-              <a:defRPr sz="2000">
-                <a:solidFill>
-                  <a:srgbClr val="2C3E50"/>
-                </a:solidFill>
-              </a:defRPr>
-            </a:pPr>
-            <a:r>
-              <a:t>  Enables biological interpretation</a:t>
-            </a:r>
-          </a:p>
-          <a:p>
-            <a:pPr>
-              <a:spcBef>
-                <a:spcPts val="1000"/>
-              </a:spcBef>
-              <a:spcAft>
-                <a:spcPts val="500"/>
-              </a:spcAft>
-              <a:defRPr sz="2000">
-                <a:solidFill>
-                  <a:srgbClr val="2C3E50"/>
-                </a:solidFill>
-              </a:defRPr>
-            </a:pPr>
-            <a:r>
-              <a:t>  Identifies tumor-reactive clonotypes</a:t>
+              <a:t>Figure 2: DeepTCR Architecture (MIL + Attention)</a:t>
             </a:r>
           </a:p>
         </p:txBody>
       </p:sp>
       <p:pic>
         <p:nvPicPr>
-          <p:cNvPr id="5" name="Picture 4" descr="figure_attention_distribution.png"/>
+          <p:cNvPr id="4" name="Picture 3" descr="figure2_architecture.png"/>
           <p:cNvPicPr>
             <a:picLocks noChangeAspect="1"/>
           </p:cNvPicPr>
@@ -6112,14 +6362,49 @@
         </p:blipFill>
         <p:spPr>
           <a:xfrm>
-            <a:off x="5943600" y="1371600"/>
-            <a:ext cx="5760720" cy="2399757"/>
+            <a:off x="640080" y="1234440"/>
+            <a:ext cx="10881360" cy="5401538"/>
           </a:xfrm>
           <a:prstGeom prst="rect">
             <a:avLst/>
           </a:prstGeom>
         </p:spPr>
       </p:pic>
+      <p:sp>
+        <p:nvSpPr>
+          <p:cNvPr id="5" name="TextBox 4"/>
+          <p:cNvSpPr txBox="1"/>
+          <p:nvPr/>
+        </p:nvSpPr>
+        <p:spPr>
+          <a:xfrm>
+            <a:off x="640080" y="5989320"/>
+            <a:ext cx="10881360" cy="731520"/>
+          </a:xfrm>
+          <a:prstGeom prst="rect">
+            <a:avLst/>
+          </a:prstGeom>
+          <a:noFill/>
+        </p:spPr>
+        <p:txBody>
+          <a:bodyPr wrap="square">
+            <a:spAutoFit/>
+          </a:bodyPr>
+          <a:lstStyle/>
+          <a:p>
+            <a:pPr>
+              <a:defRPr sz="1600">
+                <a:solidFill>
+                  <a:srgbClr val="2C3E50"/>
+                </a:solidFill>
+              </a:defRPr>
+            </a:pPr>
+            <a:r>
+              <a:t>MIL treats each patient as a bag of sequences; attention highlights predictive clonotypes</a:t>
+            </a:r>
+          </a:p>
+        </p:txBody>
+      </p:sp>
     </p:spTree>
   </p:cSld>
   <p:clrMapOvr>
@@ -6147,7 +6432,7 @@
         <p:spPr>
           <a:xfrm>
             <a:off x="0" y="0"/>
-            <a:ext cx="12191695" cy="1097280"/>
+            <a:ext cx="12191695" cy="1005840"/>
           </a:xfrm>
           <a:prstGeom prst="rect">
             <a:avLst/>
@@ -6189,7 +6474,7 @@
         </p:nvSpPr>
         <p:spPr>
           <a:xfrm>
-            <a:off x="457200" y="274320"/>
+            <a:off x="457200" y="228600"/>
             <a:ext cx="11247120" cy="731520"/>
           </a:xfrm>
           <a:prstGeom prst="rect">
@@ -6204,152 +6489,21 @@
           <a:lstStyle/>
           <a:p>
             <a:pPr>
-              <a:defRPr sz="3200" b="1">
+              <a:defRPr sz="3000" b="1">
                 <a:solidFill>
                   <a:srgbClr val="FFFFFF"/>
                 </a:solidFill>
               </a:defRPr>
             </a:pPr>
             <a:r>
-              <a:t>Responder vs Non-Responder Comparison</a:t>
-            </a:r>
-          </a:p>
-        </p:txBody>
-      </p:sp>
-      <p:sp>
-        <p:nvSpPr>
-          <p:cNvPr id="4" name="TextBox 3"/>
-          <p:cNvSpPr txBox="1"/>
-          <p:nvPr/>
-        </p:nvSpPr>
-        <p:spPr>
-          <a:xfrm>
-            <a:off x="457200" y="1371600"/>
-            <a:ext cx="5029200" cy="5029200"/>
-          </a:xfrm>
-          <a:prstGeom prst="rect">
-            <a:avLst/>
-          </a:prstGeom>
-          <a:noFill/>
-        </p:spPr>
-        <p:txBody>
-          <a:bodyPr wrap="square">
-            <a:spAutoFit/>
-          </a:bodyPr>
-          <a:lstStyle/>
-          <a:p>
-            <a:pPr>
-              <a:spcBef>
-                <a:spcPts val="1000"/>
-              </a:spcBef>
-              <a:spcAft>
-                <a:spcPts val="500"/>
-              </a:spcAft>
-              <a:defRPr sz="2000">
-                <a:solidFill>
-                  <a:srgbClr val="2C3E50"/>
-                </a:solidFill>
-              </a:defRPr>
-            </a:pPr>
-            <a:r>
-              <a:t>  Statistical comparison of TCR features</a:t>
-            </a:r>
-          </a:p>
-          <a:p>
-            <a:pPr>
-              <a:spcBef>
-                <a:spcPts val="1000"/>
-              </a:spcBef>
-              <a:spcAft>
-                <a:spcPts val="500"/>
-              </a:spcAft>
-              <a:defRPr sz="2000">
-                <a:solidFill>
-                  <a:srgbClr val="2C3E50"/>
-                </a:solidFill>
-              </a:defRPr>
-            </a:pPr>
-            <a:r>
-              <a:t>  V-gene usage patterns differ between groups</a:t>
-            </a:r>
-          </a:p>
-          <a:p>
-            <a:pPr>
-              <a:spcBef>
-                <a:spcPts val="1000"/>
-              </a:spcBef>
-              <a:spcAft>
-                <a:spcPts val="500"/>
-              </a:spcAft>
-              <a:defRPr sz="2000">
-                <a:solidFill>
-                  <a:srgbClr val="2C3E50"/>
-                </a:solidFill>
-              </a:defRPr>
-            </a:pPr>
-            <a:r>
-              <a:t>  J-gene usage shows distinct signatures</a:t>
-            </a:r>
-          </a:p>
-          <a:p>
-            <a:pPr>
-              <a:spcBef>
-                <a:spcPts val="1000"/>
-              </a:spcBef>
-              <a:spcAft>
-                <a:spcPts val="500"/>
-              </a:spcAft>
-              <a:defRPr sz="2000">
-                <a:solidFill>
-                  <a:srgbClr val="2C3E50"/>
-                </a:solidFill>
-              </a:defRPr>
-            </a:pPr>
-            <a:r>
-              <a:t>  CDR3 length distributions similar</a:t>
-            </a:r>
-          </a:p>
-          <a:p>
-            <a:pPr>
-              <a:spcBef>
-                <a:spcPts val="1000"/>
-              </a:spcBef>
-              <a:spcAft>
-                <a:spcPts val="500"/>
-              </a:spcAft>
-              <a:defRPr sz="2000">
-                <a:solidFill>
-                  <a:srgbClr val="2C3E50"/>
-                </a:solidFill>
-              </a:defRPr>
-            </a:pPr>
-            <a:r>
-              <a:t>  Attention weight distributions comparable</a:t>
-            </a:r>
-          </a:p>
-          <a:p>
-            <a:pPr>
-              <a:spcBef>
-                <a:spcPts val="1000"/>
-              </a:spcBef>
-              <a:spcAft>
-                <a:spcPts val="500"/>
-              </a:spcAft>
-              <a:defRPr sz="2000">
-                <a:solidFill>
-                  <a:srgbClr val="2C3E50"/>
-                </a:solidFill>
-              </a:defRPr>
-            </a:pPr>
-            <a:r>
-              <a:t>  Multiple instance approach captures differences</a:t>
+              <a:t>Figure 3: Cohort Overview</a:t>
             </a:r>
           </a:p>
         </p:txBody>
       </p:sp>
       <p:pic>
         <p:nvPicPr>
-          <p:cNvPr id="5" name="Picture 4" descr="figure_responder_comparison.png"/>
+          <p:cNvPr id="4" name="Picture 3" descr="figure3_cohort_overview.png"/>
           <p:cNvPicPr>
             <a:picLocks noChangeAspect="1"/>
           </p:cNvPicPr>
@@ -6363,14 +6517,49 @@
         </p:blipFill>
         <p:spPr>
           <a:xfrm>
-            <a:off x="5943600" y="1371600"/>
-            <a:ext cx="5760720" cy="4903859"/>
+            <a:off x="640080" y="1234440"/>
+            <a:ext cx="10881360" cy="9898968"/>
           </a:xfrm>
           <a:prstGeom prst="rect">
             <a:avLst/>
           </a:prstGeom>
         </p:spPr>
       </p:pic>
+      <p:sp>
+        <p:nvSpPr>
+          <p:cNvPr id="5" name="TextBox 4"/>
+          <p:cNvSpPr txBox="1"/>
+          <p:nvPr/>
+        </p:nvSpPr>
+        <p:spPr>
+          <a:xfrm>
+            <a:off x="640080" y="5989320"/>
+            <a:ext cx="10881360" cy="731520"/>
+          </a:xfrm>
+          <a:prstGeom prst="rect">
+            <a:avLst/>
+          </a:prstGeom>
+          <a:noFill/>
+        </p:spPr>
+        <p:txBody>
+          <a:bodyPr wrap="square">
+            <a:spAutoFit/>
+          </a:bodyPr>
+          <a:lstStyle/>
+          <a:p>
+            <a:pPr>
+              <a:defRPr sz="1600">
+                <a:solidFill>
+                  <a:srgbClr val="2C3E50"/>
+                </a:solidFill>
+              </a:defRPr>
+            </a:pPr>
+            <a:r>
+              <a:t>Summary of sequences per patient and cohort characteristics</a:t>
+            </a:r>
+          </a:p>
+        </p:txBody>
+      </p:sp>
     </p:spTree>
   </p:cSld>
   <p:clrMapOvr>
@@ -6462,7 +6651,7 @@
               </a:defRPr>
             </a:pPr>
             <a:r>
-              <a:t>Top Predictive Sequences</a:t>
+              <a:t>Monte Carlo Cross-Validation</a:t>
             </a:r>
           </a:p>
         </p:txBody>
@@ -6476,7 +6665,7 @@
         <p:spPr>
           <a:xfrm>
             <a:off x="457200" y="1371600"/>
-            <a:ext cx="5029200" cy="5029200"/>
+            <a:ext cx="11247120" cy="5029200"/>
           </a:xfrm>
           <a:prstGeom prst="rect">
             <a:avLst/>
@@ -6503,7 +6692,7 @@
               </a:defRPr>
             </a:pPr>
             <a:r>
-              <a:t>  Top 100 highest-attention sequences identified</a:t>
+              <a:t>  100-fold Monte Carlo Cross-Validation</a:t>
             </a:r>
           </a:p>
           <a:p>
@@ -6521,7 +6710,7 @@
               </a:defRPr>
             </a:pPr>
             <a:r>
-              <a:t>  V-gene enrichment in predictive sequences</a:t>
+              <a:t>  Each fold: 75% train, 25% test</a:t>
             </a:r>
           </a:p>
           <a:p>
@@ -6539,7 +6728,7 @@
               </a:defRPr>
             </a:pPr>
             <a:r>
-              <a:t>  J-gene preferences for high attention</a:t>
+              <a:t>  Random patient-level splits</a:t>
             </a:r>
           </a:p>
           <a:p>
@@ -6557,7 +6746,7 @@
               </a:defRPr>
             </a:pPr>
             <a:r>
-              <a:t>  Sequences associated with tumor recognition</a:t>
+              <a:t>  Prevents overfitting to specific splits</a:t>
             </a:r>
           </a:p>
           <a:p>
@@ -6575,7 +6764,7 @@
               </a:defRPr>
             </a:pPr>
             <a:r>
-              <a:t>  Potential biomarkers for response prediction</a:t>
+              <a:t>  Robust performance estimation</a:t>
             </a:r>
           </a:p>
           <a:p>
@@ -6593,35 +6782,11 @@
               </a:defRPr>
             </a:pPr>
             <a:r>
-              <a:t>  Foundation for mechanistic studies</a:t>
-            </a:r>
-          </a:p>
-        </p:txBody>
-      </p:sp>
-      <p:pic>
-        <p:nvPicPr>
-          <p:cNvPr id="5" name="Picture 4" descr="figure_top_sequences.png"/>
-          <p:cNvPicPr>
-            <a:picLocks noChangeAspect="1"/>
-          </p:cNvPicPr>
-          <p:nvPr/>
-        </p:nvPicPr>
-        <p:blipFill>
-          <a:blip r:embed="rId2"/>
-          <a:stretch>
-            <a:fillRect/>
-          </a:stretch>
-        </p:blipFill>
-        <p:spPr>
-          <a:xfrm>
-            <a:off x="5943600" y="1371600"/>
-            <a:ext cx="5760720" cy="4758316"/>
-          </a:xfrm>
-          <a:prstGeom prst="rect">
-            <a:avLst/>
-          </a:prstGeom>
-        </p:spPr>
-      </p:pic>
+              <a:t>  Training time: ~35 minutes (H100 GPU)</a:t>
+            </a:r>
+          </a:p>
+        </p:txBody>
+      </p:sp>
     </p:spTree>
   </p:cSld>
   <p:clrMapOvr>

</xml_diff>

<commit_message>
feat: Add unsupervised clustering validation script and figures
Co-authored-by: jahanmateenah55 <jahanmateenah55@gmail.com>
</commit_message>
<xml_diff>
--- a/results/DeepTCR_Results_Presentation.pptx
+++ b/results/DeepTCR_Results_Presentation.pptx
@@ -25,6 +25,7 @@
     <p:sldId id="273" r:id="rId24"/>
     <p:sldId id="274" r:id="rId25"/>
     <p:sldId id="275" r:id="rId26"/>
+    <p:sldId id="276" r:id="rId27"/>
   </p:sldIdLst>
   <p:sldSz cx="12191695" cy="6858000" type="screen4x3"/>
   <p:notesSz cx="6858000" cy="9144000"/>
@@ -4587,7 +4588,7 @@
         <p:spPr>
           <a:xfrm>
             <a:off x="0" y="0"/>
-            <a:ext cx="12191695" cy="1097280"/>
+            <a:ext cx="12191695" cy="1005840"/>
           </a:xfrm>
           <a:prstGeom prst="rect">
             <a:avLst/>
@@ -4629,7 +4630,7 @@
         </p:nvSpPr>
         <p:spPr>
           <a:xfrm>
-            <a:off x="457200" y="274320"/>
+            <a:off x="457200" y="228600"/>
             <a:ext cx="11247120" cy="731520"/>
           </a:xfrm>
           <a:prstGeom prst="rect">
@@ -4644,28 +4645,52 @@
           <a:lstStyle/>
           <a:p>
             <a:pPr>
-              <a:defRPr sz="3200" b="1">
+              <a:defRPr sz="3000" b="1">
                 <a:solidFill>
                   <a:srgbClr val="FFFFFF"/>
                 </a:solidFill>
               </a:defRPr>
             </a:pPr>
             <a:r>
-              <a:t>Key Findings Summary</a:t>
-            </a:r>
-          </a:p>
-        </p:txBody>
-      </p:sp>
-      <p:sp>
-        <p:nvSpPr>
-          <p:cNvPr id="4" name="TextBox 3"/>
+              <a:t>Figure S15: Unsupervised Validation (Quality + Stability)</a:t>
+            </a:r>
+          </a:p>
+        </p:txBody>
+      </p:sp>
+      <p:pic>
+        <p:nvPicPr>
+          <p:cNvPr id="4" name="Picture 3" descr="figureS15_unsupervised_validation.png"/>
+          <p:cNvPicPr>
+            <a:picLocks noChangeAspect="1"/>
+          </p:cNvPicPr>
+          <p:nvPr/>
+        </p:nvPicPr>
+        <p:blipFill>
+          <a:blip r:embed="rId2"/>
+          <a:stretch>
+            <a:fillRect/>
+          </a:stretch>
+        </p:blipFill>
+        <p:spPr>
+          <a:xfrm>
+            <a:off x="640080" y="1234440"/>
+            <a:ext cx="10881360" cy="3392271"/>
+          </a:xfrm>
+          <a:prstGeom prst="rect">
+            <a:avLst/>
+          </a:prstGeom>
+        </p:spPr>
+      </p:pic>
+      <p:sp>
+        <p:nvSpPr>
+          <p:cNvPr id="5" name="TextBox 4"/>
           <p:cNvSpPr txBox="1"/>
           <p:nvPr/>
         </p:nvSpPr>
         <p:spPr>
           <a:xfrm>
-            <a:off x="457200" y="1371600"/>
-            <a:ext cx="5303520" cy="5029200"/>
+            <a:off x="640080" y="5989320"/>
+            <a:ext cx="10881360" cy="731520"/>
           </a:xfrm>
           <a:prstGeom prst="rect">
             <a:avLst/>
@@ -4679,205 +4704,14 @@
           <a:lstStyle/>
           <a:p>
             <a:pPr>
-              <a:spcBef>
-                <a:spcPts val="800"/>
-              </a:spcBef>
-              <a:defRPr sz="1800">
+              <a:defRPr sz="1600">
                 <a:solidFill>
                   <a:srgbClr val="2C3E50"/>
                 </a:solidFill>
               </a:defRPr>
             </a:pPr>
             <a:r>
-              <a:t>  Supervised MIL:</a:t>
-            </a:r>
-          </a:p>
-          <a:p>
-            <a:pPr>
-              <a:spcBef>
-                <a:spcPts val="800"/>
-              </a:spcBef>
-              <a:defRPr sz="1800">
-                <a:solidFill>
-                  <a:srgbClr val="2C3E50"/>
-                </a:solidFill>
-              </a:defRPr>
-            </a:pPr>
-            <a:r>
-              <a:t>     Mean AUC ≈ 0.754</a:t>
-            </a:r>
-          </a:p>
-          <a:p>
-            <a:pPr>
-              <a:spcBef>
-                <a:spcPts val="800"/>
-              </a:spcBef>
-              <a:defRPr sz="1800">
-                <a:solidFill>
-                  <a:srgbClr val="2C3E50"/>
-                </a:solidFill>
-              </a:defRPr>
-            </a:pPr>
-            <a:r>
-              <a:t>     Attention identifies predictive clonotypes</a:t>
-            </a:r>
-          </a:p>
-          <a:p>
-            <a:pPr>
-              <a:spcBef>
-                <a:spcPts val="800"/>
-              </a:spcBef>
-              <a:defRPr sz="1800">
-                <a:solidFill>
-                  <a:srgbClr val="2C3E50"/>
-                </a:solidFill>
-              </a:defRPr>
-            </a:pPr>
-            <a:r>
-              <a:t>  </a:t>
-            </a:r>
-          </a:p>
-          <a:p>
-            <a:pPr>
-              <a:spcBef>
-                <a:spcPts val="800"/>
-              </a:spcBef>
-              <a:defRPr sz="1800">
-                <a:solidFill>
-                  <a:srgbClr val="2C3E50"/>
-                </a:solidFill>
-              </a:defRPr>
-            </a:pPr>
-            <a:r>
-              <a:t>  Unsupervised:</a:t>
-            </a:r>
-          </a:p>
-          <a:p>
-            <a:pPr>
-              <a:spcBef>
-                <a:spcPts val="800"/>
-              </a:spcBef>
-              <a:defRPr sz="1800">
-                <a:solidFill>
-                  <a:srgbClr val="2C3E50"/>
-                </a:solidFill>
-              </a:defRPr>
-            </a:pPr>
-            <a:r>
-              <a:t>     UMAP visualizes sequence concepts</a:t>
-            </a:r>
-          </a:p>
-          <a:p>
-            <a:pPr>
-              <a:spcBef>
-                <a:spcPts val="800"/>
-              </a:spcBef>
-              <a:defRPr sz="1800">
-                <a:solidFill>
-                  <a:srgbClr val="2C3E50"/>
-                </a:solidFill>
-              </a:defRPr>
-            </a:pPr>
-            <a:r>
-              <a:t>     Patient embedding provides structural QC</a:t>
-            </a:r>
-          </a:p>
-        </p:txBody>
-      </p:sp>
-      <p:sp>
-        <p:nvSpPr>
-          <p:cNvPr id="5" name="TextBox 4"/>
-          <p:cNvSpPr txBox="1"/>
-          <p:nvPr/>
-        </p:nvSpPr>
-        <p:spPr>
-          <a:xfrm>
-            <a:off x="6217920" y="1371600"/>
-            <a:ext cx="5303520" cy="5029200"/>
-          </a:xfrm>
-          <a:prstGeom prst="rect">
-            <a:avLst/>
-          </a:prstGeom>
-          <a:noFill/>
-        </p:spPr>
-        <p:txBody>
-          <a:bodyPr wrap="square">
-            <a:spAutoFit/>
-          </a:bodyPr>
-          <a:lstStyle/>
-          <a:p>
-            <a:pPr>
-              <a:spcBef>
-                <a:spcPts val="800"/>
-              </a:spcBef>
-              <a:defRPr sz="1800">
-                <a:solidFill>
-                  <a:srgbClr val="2C3E50"/>
-                </a:solidFill>
-              </a:defRPr>
-            </a:pPr>
-            <a:r>
-              <a:t>  Clinical message:</a:t>
-            </a:r>
-          </a:p>
-          <a:p>
-            <a:pPr>
-              <a:spcBef>
-                <a:spcPts val="800"/>
-              </a:spcBef>
-              <a:defRPr sz="1800">
-                <a:solidFill>
-                  <a:srgbClr val="2C3E50"/>
-                </a:solidFill>
-              </a:defRPr>
-            </a:pPr>
-            <a:r>
-              <a:t>     Potential pre-therapy biomarker signal from TCR repertoire</a:t>
-            </a:r>
-          </a:p>
-          <a:p>
-            <a:pPr>
-              <a:spcBef>
-                <a:spcPts val="800"/>
-              </a:spcBef>
-              <a:defRPr sz="1800">
-                <a:solidFill>
-                  <a:srgbClr val="2C3E50"/>
-                </a:solidFill>
-              </a:defRPr>
-            </a:pPr>
-            <a:r>
-              <a:t>  </a:t>
-            </a:r>
-          </a:p>
-          <a:p>
-            <a:pPr>
-              <a:spcBef>
-                <a:spcPts val="800"/>
-              </a:spcBef>
-              <a:defRPr sz="1800">
-                <a:solidFill>
-                  <a:srgbClr val="2C3E50"/>
-                </a:solidFill>
-              </a:defRPr>
-            </a:pPr>
-            <a:r>
-              <a:t>  Interpretability:</a:t>
-            </a:r>
-          </a:p>
-          <a:p>
-            <a:pPr>
-              <a:spcBef>
-                <a:spcPts val="800"/>
-              </a:spcBef>
-              <a:defRPr sz="1800">
-                <a:solidFill>
-                  <a:srgbClr val="2C3E50"/>
-                </a:solidFill>
-              </a:defRPr>
-            </a:pPr>
-            <a:r>
-              <a:t>     High-attention sequences map to localized regions in sequence space</a:t>
+              <a:t>Shows internal clustering quality and stability across k values</a:t>
             </a:r>
           </a:p>
         </p:txBody>
@@ -4973,7 +4807,7 @@
               </a:defRPr>
             </a:pPr>
             <a:r>
-              <a:t>Limitations &amp; Next Steps</a:t>
+              <a:t>Key Findings Summary</a:t>
             </a:r>
           </a:p>
         </p:txBody>
@@ -4987,7 +4821,7 @@
         <p:spPr>
           <a:xfrm>
             <a:off x="457200" y="1371600"/>
-            <a:ext cx="11247120" cy="5029200"/>
+            <a:ext cx="5303520" cy="5029200"/>
           </a:xfrm>
           <a:prstGeom prst="rect">
             <a:avLst/>
@@ -5002,73 +4836,204 @@
           <a:p>
             <a:pPr>
               <a:spcBef>
-                <a:spcPts val="1000"/>
+                <a:spcPts val="800"/>
               </a:spcBef>
-              <a:spcAft>
-                <a:spcPts val="500"/>
-              </a:spcAft>
-              <a:defRPr sz="2000">
+              <a:defRPr sz="1800">
                 <a:solidFill>
                   <a:srgbClr val="2C3E50"/>
                 </a:solidFill>
               </a:defRPr>
             </a:pPr>
             <a:r>
-              <a:t>  Small cohort size (n=34) → needs external validation</a:t>
+              <a:t>  Supervised MIL:</a:t>
             </a:r>
           </a:p>
           <a:p>
             <a:pPr>
               <a:spcBef>
-                <a:spcPts val="1000"/>
+                <a:spcPts val="800"/>
               </a:spcBef>
-              <a:spcAft>
-                <a:spcPts val="500"/>
-              </a:spcAft>
-              <a:defRPr sz="2000">
+              <a:defRPr sz="1800">
                 <a:solidFill>
                   <a:srgbClr val="2C3E50"/>
                 </a:solidFill>
               </a:defRPr>
             </a:pPr>
             <a:r>
-              <a:t>  No HLA available (unlike Sidhom 2022 TCR+HLA models)</a:t>
+              <a:t>     Mean AUC ≈ 0.754</a:t>
             </a:r>
           </a:p>
           <a:p>
             <a:pPr>
               <a:spcBef>
-                <a:spcPts val="1000"/>
+                <a:spcPts val="800"/>
               </a:spcBef>
-              <a:spcAft>
-                <a:spcPts val="500"/>
-              </a:spcAft>
-              <a:defRPr sz="2000">
+              <a:defRPr sz="1800">
                 <a:solidFill>
                   <a:srgbClr val="2C3E50"/>
                 </a:solidFill>
               </a:defRPr>
             </a:pPr>
             <a:r>
-              <a:t>  Improve: add more patients, integrate clinical covariates, prospective evaluation</a:t>
+              <a:t>     Attention identifies predictive clonotypes</a:t>
             </a:r>
           </a:p>
           <a:p>
             <a:pPr>
               <a:spcBef>
-                <a:spcPts val="1000"/>
+                <a:spcPts val="800"/>
               </a:spcBef>
-              <a:spcAft>
-                <a:spcPts val="500"/>
-              </a:spcAft>
-              <a:defRPr sz="2000">
+              <a:defRPr sz="1800">
                 <a:solidFill>
                   <a:srgbClr val="2C3E50"/>
                 </a:solidFill>
               </a:defRPr>
             </a:pPr>
             <a:r>
-              <a:t>  Biology: validate high-attention clonotypes and motifs experimentally</a:t>
+              <a:t>  </a:t>
+            </a:r>
+          </a:p>
+          <a:p>
+            <a:pPr>
+              <a:spcBef>
+                <a:spcPts val="800"/>
+              </a:spcBef>
+              <a:defRPr sz="1800">
+                <a:solidFill>
+                  <a:srgbClr val="2C3E50"/>
+                </a:solidFill>
+              </a:defRPr>
+            </a:pPr>
+            <a:r>
+              <a:t>  Unsupervised:</a:t>
+            </a:r>
+          </a:p>
+          <a:p>
+            <a:pPr>
+              <a:spcBef>
+                <a:spcPts val="800"/>
+              </a:spcBef>
+              <a:defRPr sz="1800">
+                <a:solidFill>
+                  <a:srgbClr val="2C3E50"/>
+                </a:solidFill>
+              </a:defRPr>
+            </a:pPr>
+            <a:r>
+              <a:t>     UMAP visualizes sequence concepts</a:t>
+            </a:r>
+          </a:p>
+          <a:p>
+            <a:pPr>
+              <a:spcBef>
+                <a:spcPts val="800"/>
+              </a:spcBef>
+              <a:defRPr sz="1800">
+                <a:solidFill>
+                  <a:srgbClr val="2C3E50"/>
+                </a:solidFill>
+              </a:defRPr>
+            </a:pPr>
+            <a:r>
+              <a:t>     Patient embedding provides structural QC</a:t>
+            </a:r>
+          </a:p>
+        </p:txBody>
+      </p:sp>
+      <p:sp>
+        <p:nvSpPr>
+          <p:cNvPr id="5" name="TextBox 4"/>
+          <p:cNvSpPr txBox="1"/>
+          <p:nvPr/>
+        </p:nvSpPr>
+        <p:spPr>
+          <a:xfrm>
+            <a:off x="6217920" y="1371600"/>
+            <a:ext cx="5303520" cy="5029200"/>
+          </a:xfrm>
+          <a:prstGeom prst="rect">
+            <a:avLst/>
+          </a:prstGeom>
+          <a:noFill/>
+        </p:spPr>
+        <p:txBody>
+          <a:bodyPr wrap="square">
+            <a:spAutoFit/>
+          </a:bodyPr>
+          <a:lstStyle/>
+          <a:p>
+            <a:pPr>
+              <a:spcBef>
+                <a:spcPts val="800"/>
+              </a:spcBef>
+              <a:defRPr sz="1800">
+                <a:solidFill>
+                  <a:srgbClr val="2C3E50"/>
+                </a:solidFill>
+              </a:defRPr>
+            </a:pPr>
+            <a:r>
+              <a:t>  Clinical message:</a:t>
+            </a:r>
+          </a:p>
+          <a:p>
+            <a:pPr>
+              <a:spcBef>
+                <a:spcPts val="800"/>
+              </a:spcBef>
+              <a:defRPr sz="1800">
+                <a:solidFill>
+                  <a:srgbClr val="2C3E50"/>
+                </a:solidFill>
+              </a:defRPr>
+            </a:pPr>
+            <a:r>
+              <a:t>     Potential pre-therapy biomarker signal from TCR repertoire</a:t>
+            </a:r>
+          </a:p>
+          <a:p>
+            <a:pPr>
+              <a:spcBef>
+                <a:spcPts val="800"/>
+              </a:spcBef>
+              <a:defRPr sz="1800">
+                <a:solidFill>
+                  <a:srgbClr val="2C3E50"/>
+                </a:solidFill>
+              </a:defRPr>
+            </a:pPr>
+            <a:r>
+              <a:t>  </a:t>
+            </a:r>
+          </a:p>
+          <a:p>
+            <a:pPr>
+              <a:spcBef>
+                <a:spcPts val="800"/>
+              </a:spcBef>
+              <a:defRPr sz="1800">
+                <a:solidFill>
+                  <a:srgbClr val="2C3E50"/>
+                </a:solidFill>
+              </a:defRPr>
+            </a:pPr>
+            <a:r>
+              <a:t>  Interpretability:</a:t>
+            </a:r>
+          </a:p>
+          <a:p>
+            <a:pPr>
+              <a:spcBef>
+                <a:spcPts val="800"/>
+              </a:spcBef>
+              <a:defRPr sz="1800">
+                <a:solidFill>
+                  <a:srgbClr val="2C3E50"/>
+                </a:solidFill>
+              </a:defRPr>
+            </a:pPr>
+            <a:r>
+              <a:t>     High-attention sequences map to localized regions in sequence space</a:t>
             </a:r>
           </a:p>
         </p:txBody>
@@ -5291,6 +5256,197 @@
 </file>
 
 <file path=ppt/slides/slide20.xml><?xml version="1.0" encoding="utf-8"?>
+<p:sld xmlns:a="http://schemas.openxmlformats.org/drawingml/2006/main" xmlns:p="http://schemas.openxmlformats.org/presentationml/2006/main" xmlns:r="http://schemas.openxmlformats.org/officeDocument/2006/relationships">
+  <p:cSld>
+    <p:spTree>
+      <p:nvGrpSpPr>
+        <p:cNvPr id="1" name=""/>
+        <p:cNvGrpSpPr/>
+        <p:nvPr/>
+      </p:nvGrpSpPr>
+      <p:grpSpPr/>
+      <p:sp>
+        <p:nvSpPr>
+          <p:cNvPr id="2" name="Rectangle 1"/>
+          <p:cNvSpPr/>
+          <p:nvPr/>
+        </p:nvSpPr>
+        <p:spPr>
+          <a:xfrm>
+            <a:off x="0" y="0"/>
+            <a:ext cx="12191695" cy="1097280"/>
+          </a:xfrm>
+          <a:prstGeom prst="rect">
+            <a:avLst/>
+          </a:prstGeom>
+          <a:solidFill>
+            <a:srgbClr val="2C3E50"/>
+          </a:solidFill>
+          <a:ln>
+            <a:noFill/>
+          </a:ln>
+        </p:spPr>
+        <p:style>
+          <a:lnRef idx="1">
+            <a:schemeClr val="accent1"/>
+          </a:lnRef>
+          <a:fillRef idx="3">
+            <a:schemeClr val="accent1"/>
+          </a:fillRef>
+          <a:effectRef idx="2">
+            <a:schemeClr val="accent1"/>
+          </a:effectRef>
+          <a:fontRef idx="minor">
+            <a:schemeClr val="lt1"/>
+          </a:fontRef>
+        </p:style>
+        <p:txBody>
+          <a:bodyPr rtlCol="0" anchor="ctr"/>
+          <a:lstStyle/>
+          <a:p>
+            <a:pPr algn="ctr"/>
+          </a:p>
+        </p:txBody>
+      </p:sp>
+      <p:sp>
+        <p:nvSpPr>
+          <p:cNvPr id="3" name="TextBox 2"/>
+          <p:cNvSpPr txBox="1"/>
+          <p:nvPr/>
+        </p:nvSpPr>
+        <p:spPr>
+          <a:xfrm>
+            <a:off x="457200" y="274320"/>
+            <a:ext cx="11247120" cy="731520"/>
+          </a:xfrm>
+          <a:prstGeom prst="rect">
+            <a:avLst/>
+          </a:prstGeom>
+          <a:noFill/>
+        </p:spPr>
+        <p:txBody>
+          <a:bodyPr wrap="none">
+            <a:spAutoFit/>
+          </a:bodyPr>
+          <a:lstStyle/>
+          <a:p>
+            <a:pPr>
+              <a:defRPr sz="3200" b="1">
+                <a:solidFill>
+                  <a:srgbClr val="FFFFFF"/>
+                </a:solidFill>
+              </a:defRPr>
+            </a:pPr>
+            <a:r>
+              <a:t>Limitations &amp; Next Steps</a:t>
+            </a:r>
+          </a:p>
+        </p:txBody>
+      </p:sp>
+      <p:sp>
+        <p:nvSpPr>
+          <p:cNvPr id="4" name="TextBox 3"/>
+          <p:cNvSpPr txBox="1"/>
+          <p:nvPr/>
+        </p:nvSpPr>
+        <p:spPr>
+          <a:xfrm>
+            <a:off x="457200" y="1371600"/>
+            <a:ext cx="11247120" cy="5029200"/>
+          </a:xfrm>
+          <a:prstGeom prst="rect">
+            <a:avLst/>
+          </a:prstGeom>
+          <a:noFill/>
+        </p:spPr>
+        <p:txBody>
+          <a:bodyPr wrap="square">
+            <a:spAutoFit/>
+          </a:bodyPr>
+          <a:lstStyle/>
+          <a:p>
+            <a:pPr>
+              <a:spcBef>
+                <a:spcPts val="1000"/>
+              </a:spcBef>
+              <a:spcAft>
+                <a:spcPts val="500"/>
+              </a:spcAft>
+              <a:defRPr sz="2000">
+                <a:solidFill>
+                  <a:srgbClr val="2C3E50"/>
+                </a:solidFill>
+              </a:defRPr>
+            </a:pPr>
+            <a:r>
+              <a:t>  Small cohort size (n=34) → needs external validation</a:t>
+            </a:r>
+          </a:p>
+          <a:p>
+            <a:pPr>
+              <a:spcBef>
+                <a:spcPts val="1000"/>
+              </a:spcBef>
+              <a:spcAft>
+                <a:spcPts val="500"/>
+              </a:spcAft>
+              <a:defRPr sz="2000">
+                <a:solidFill>
+                  <a:srgbClr val="2C3E50"/>
+                </a:solidFill>
+              </a:defRPr>
+            </a:pPr>
+            <a:r>
+              <a:t>  No HLA available (unlike Sidhom 2022 TCR+HLA models)</a:t>
+            </a:r>
+          </a:p>
+          <a:p>
+            <a:pPr>
+              <a:spcBef>
+                <a:spcPts val="1000"/>
+              </a:spcBef>
+              <a:spcAft>
+                <a:spcPts val="500"/>
+              </a:spcAft>
+              <a:defRPr sz="2000">
+                <a:solidFill>
+                  <a:srgbClr val="2C3E50"/>
+                </a:solidFill>
+              </a:defRPr>
+            </a:pPr>
+            <a:r>
+              <a:t>  Improve: add more patients, integrate clinical covariates, prospective evaluation</a:t>
+            </a:r>
+          </a:p>
+          <a:p>
+            <a:pPr>
+              <a:spcBef>
+                <a:spcPts val="1000"/>
+              </a:spcBef>
+              <a:spcAft>
+                <a:spcPts val="500"/>
+              </a:spcAft>
+              <a:defRPr sz="2000">
+                <a:solidFill>
+                  <a:srgbClr val="2C3E50"/>
+                </a:solidFill>
+              </a:defRPr>
+            </a:pPr>
+            <a:r>
+              <a:t>  Biology: validate high-attention clonotypes and motifs experimentally</a:t>
+            </a:r>
+          </a:p>
+        </p:txBody>
+      </p:sp>
+    </p:spTree>
+  </p:cSld>
+  <p:clrMapOvr>
+    <a:masterClrMapping/>
+  </p:clrMapOvr>
+</p:sld>
+</file>
+
+<file path=ppt/slides/slide21.xml><?xml version="1.0" encoding="utf-8"?>
 <p:sld xmlns:a="http://schemas.openxmlformats.org/drawingml/2006/main" xmlns:p="http://schemas.openxmlformats.org/presentationml/2006/main" xmlns:r="http://schemas.openxmlformats.org/officeDocument/2006/relationships">
   <p:cSld>
     <p:spTree>

</xml_diff>